<commit_message>
v0.7.12.14: Remove switching cost bullet from limitations slide
Co-Authored-By: Claude Opus 4.6 <noreply@anthropic.com>
</commit_message>
<xml_diff>
--- a/writing/presentation/task_embeddings_deck.pptx
+++ b/writing/presentation/task_embeddings_deck.pptx
@@ -5069,35 +5069,6 @@
                 <a:ea typeface="Calibri" pitchFamily="34" charset="-122"/>
                 <a:cs typeface="Calibri" pitchFamily="34" charset="-120"/>
               </a:rPr>
-              <a:t>Switching cost identification failed: occupation-mean wages ≠ entry wages.</a:t>
-            </a:r>
-            <a:endParaRPr lang="en-US" sz="1400" dirty="0"/>
-          </a:p>
-          <a:p>
-            <a:pPr indent="0" marL="0">
-              <a:lnSpc>
-                <a:spcPct val="130000"/>
-              </a:lnSpc>
-              <a:buNone/>
-            </a:pPr>
-            <a:endParaRPr lang="en-US" sz="1400" dirty="0"/>
-          </a:p>
-          <a:p>
-            <a:pPr indent="0" marL="0">
-              <a:lnSpc>
-                <a:spcPct val="130000"/>
-              </a:lnSpc>
-              <a:buNone/>
-            </a:pPr>
-            <a:r>
-              <a:rPr lang="en-US" sz="1400" dirty="0">
-                <a:solidFill>
-                  <a:srgbClr val="2D2D2D"/>
-                </a:solidFill>
-                <a:latin typeface="Calibri" pitchFamily="34" charset="0"/>
-                <a:ea typeface="Calibri" pitchFamily="34" charset="-122"/>
-                <a:cs typeface="Calibri" pitchFamily="34" charset="-120"/>
-              </a:rPr>
               <a:t>Single embedding model (MPNet). Domain-specific models could differ.</a:t>
             </a:r>
             <a:endParaRPr lang="en-US" sz="1400" dirty="0"/>

</xml_diff>

<commit_message>
v0.7.12.15: Presentation — observed exposure fig, logit spec, parameter table
Co-Authored-By: Claude Opus 4.6 <noreply@anthropic.com>
</commit_message>
<xml_diff>
--- a/writing/presentation/task_embeddings_deck.pptx
+++ b/writing/presentation/task_embeddings_deck.pptx
@@ -4397,6 +4397,45 @@
         </p:nvSpPr>
         <p:spPr>
           <a:xfrm>
+            <a:off x="914400" y="3108960"/>
+            <a:ext cx="7315200" cy="457200"/>
+          </a:xfrm>
+          <a:prstGeom prst="rect">
+            <a:avLst/>
+          </a:prstGeom>
+          <a:noFill/>
+          <a:ln/>
+        </p:spPr>
+        <p:txBody>
+          <a:bodyPr wrap="square" rtlCol="0" anchor="ctr"/>
+          <a:lstStyle/>
+          <a:p>
+            <a:pPr algn="ctr" indent="0" marL="0">
+              <a:buNone/>
+            </a:pPr>
+            <a:r>
+              <a:rPr lang="en-US" sz="1600" dirty="0">
+                <a:solidFill>
+                  <a:srgbClr val="2D2D2D"/>
+                </a:solidFill>
+                <a:latin typeface="Courier New" pitchFamily="34" charset="0"/>
+                <a:ea typeface="Courier New" pitchFamily="34" charset="-122"/>
+                <a:cs typeface="Courier New" pitchFamily="34" charset="-120"/>
+              </a:rPr>
+              <a:t>P(j | i)  ∝  exp( −α · d_sem(i,j)  −  β · d_inst(i,j) )</a:t>
+            </a:r>
+            <a:endParaRPr lang="en-US" sz="1600" dirty="0"/>
+          </a:p>
+        </p:txBody>
+      </p:sp>
+      <p:sp>
+        <p:nvSpPr>
+          <p:cNvPr id="8" name="Text 5"/>
+          <p:cNvSpPr/>
+          <p:nvPr/>
+        </p:nvSpPr>
+        <p:spPr>
+          <a:xfrm>
             <a:off x="457200" y="3657600"/>
             <a:ext cx="8229600" cy="457200"/>
           </a:xfrm>
@@ -4577,14 +4616,866 @@
         </p:blipFill>
         <p:spPr>
           <a:xfrm>
-            <a:off x="457200" y="914400"/>
-            <a:ext cx="8229600" cy="3749040"/>
+            <a:off x="182880" y="914400"/>
+            <a:ext cx="5303520" cy="3749040"/>
           </a:xfrm>
           <a:prstGeom prst="rect">
             <a:avLst/>
           </a:prstGeom>
         </p:spPr>
       </p:pic>
+      <p:sp>
+        <p:nvSpPr>
+          <p:cNvPr id="6" name="Text 3"/>
+          <p:cNvSpPr/>
+          <p:nvPr/>
+        </p:nvSpPr>
+        <p:spPr>
+          <a:xfrm>
+            <a:off x="5669280" y="1005840"/>
+            <a:ext cx="3017520" cy="365760"/>
+          </a:xfrm>
+          <a:prstGeom prst="rect">
+            <a:avLst/>
+          </a:prstGeom>
+          <a:noFill/>
+          <a:ln/>
+        </p:spPr>
+        <p:txBody>
+          <a:bodyPr wrap="square" rtlCol="0" anchor="ctr"/>
+          <a:lstStyle/>
+          <a:p>
+            <a:pPr algn="ctr" indent="0" marL="0">
+              <a:buNone/>
+            </a:pPr>
+            <a:r>
+              <a:rPr lang="en-US" sz="1300" b="1" dirty="0">
+                <a:solidFill>
+                  <a:srgbClr val="2D2D2D"/>
+                </a:solidFill>
+                <a:latin typeface="Calibri" pitchFamily="34" charset="0"/>
+                <a:ea typeface="Calibri" pitchFamily="34" charset="-122"/>
+                <a:cs typeface="Calibri" pitchFamily="34" charset="-120"/>
+              </a:rPr>
+              <a:t>Embedding × Centroid</a:t>
+            </a:r>
+            <a:endParaRPr lang="en-US" sz="1300" dirty="0"/>
+          </a:p>
+        </p:txBody>
+      </p:sp>
+      <p:graphicFrame>
+        <p:nvGraphicFramePr>
+          <p:cNvPr id="8" name="Table 0"/>
+          <p:cNvGraphicFramePr>
+            <a:graphicFrameLocks noGrp="1"/>
+          </p:cNvGraphicFramePr>
+          <p:nvPr>
+            <p:extLst>
+              <p:ext uri="{D42A27DB-BD31-4B8C-83A1-F6EECF244321}">
+                <p14:modId xmlns:p14="http://schemas.microsoft.com/office/powerpoint/2010/main" val="1579011935"/>
+              </p:ext>
+            </p:extLst>
+          </p:nvPr>
+        </p:nvGraphicFramePr>
+        <p:xfrm>
+          <a:off x="5669280" y="1463040"/>
+          <a:ext cx="3017520" cy="1097280"/>
+        </p:xfrm>
+        <a:graphic>
+          <a:graphicData uri="http://schemas.openxmlformats.org/drawingml/2006/table">
+            <a:tbl>
+              <a:tblPr/>
+              <a:tblGrid>
+                <a:gridCol w="1280160"/>
+                <a:gridCol w="822960"/>
+                <a:gridCol w="822960"/>
+              </a:tblGrid>
+              <a:tr h="320040">
+                <a:tc>
+                  <a:txBody>
+                    <a:bodyPr/>
+                    <a:lstStyle/>
+                    <a:p>
+                      <a:pPr algn="ctr" indent="0" marL="0">
+                        <a:buNone/>
+                      </a:pPr>
+                      <a:r>
+                        <a:rPr lang="en-US" sz="1100" b="1" dirty="0">
+                          <a:solidFill>
+                            <a:srgbClr val="FFFFFF"/>
+                          </a:solidFill>
+                          <a:latin typeface="Calibri" pitchFamily="34" charset="0"/>
+                          <a:ea typeface="Calibri" pitchFamily="34" charset="-122"/>
+                          <a:cs typeface="Calibri" pitchFamily="34" charset="-120"/>
+                        </a:rPr>
+                        <a:t>Parameter</a:t>
+                      </a:r>
+                      <a:endParaRPr lang="en-US" sz="1100" dirty="0">
+                        <a:latin typeface="Calibri" charset="0"/>
+                        <a:ea typeface="Calibri" charset="0"/>
+                        <a:cs typeface="Calibri" charset="0"/>
+                      </a:endParaRPr>
+                    </a:p>
+                  </a:txBody>
+                  <a:tcPr marL="91440" marR="91440" marT="45720" marB="45720" anchor="ctr">
+                    <a:lnL w="6350" cap="flat" cmpd="sng" algn="ctr">
+                      <a:solidFill>
+                        <a:srgbClr val="DDDDDD"/>
+                      </a:solidFill>
+                      <a:prstDash val="solid"/>
+                      <a:round/>
+                      <a:headEnd type="none" w="med" len="med"/>
+                      <a:tailEnd type="none" w="med" len="med"/>
+                    </a:lnL>
+                    <a:lnR w="6350" cap="flat" cmpd="sng" algn="ctr">
+                      <a:solidFill>
+                        <a:srgbClr val="DDDDDD"/>
+                      </a:solidFill>
+                      <a:prstDash val="solid"/>
+                      <a:round/>
+                      <a:headEnd type="none" w="med" len="med"/>
+                      <a:tailEnd type="none" w="med" len="med"/>
+                    </a:lnR>
+                    <a:lnT w="6350" cap="flat" cmpd="sng" algn="ctr">
+                      <a:solidFill>
+                        <a:srgbClr val="DDDDDD"/>
+                      </a:solidFill>
+                      <a:prstDash val="solid"/>
+                      <a:round/>
+                      <a:headEnd type="none" w="med" len="med"/>
+                      <a:tailEnd type="none" w="med" len="med"/>
+                    </a:lnT>
+                    <a:lnB w="6350" cap="flat" cmpd="sng" algn="ctr">
+                      <a:solidFill>
+                        <a:srgbClr val="DDDDDD"/>
+                      </a:solidFill>
+                      <a:prstDash val="solid"/>
+                      <a:round/>
+                      <a:headEnd type="none" w="med" len="med"/>
+                      <a:tailEnd type="none" w="med" len="med"/>
+                    </a:lnB>
+                    <a:solidFill>
+                      <a:srgbClr val="4A7FB5"/>
+                    </a:solidFill>
+                  </a:tcPr>
+                </a:tc>
+                <a:tc>
+                  <a:txBody>
+                    <a:bodyPr/>
+                    <a:lstStyle/>
+                    <a:p>
+                      <a:pPr algn="ctr" indent="0" marL="0">
+                        <a:buNone/>
+                      </a:pPr>
+                      <a:r>
+                        <a:rPr lang="en-US" sz="1100" b="1" dirty="0">
+                          <a:solidFill>
+                            <a:srgbClr val="FFFFFF"/>
+                          </a:solidFill>
+                          <a:latin typeface="Calibri" pitchFamily="34" charset="0"/>
+                          <a:ea typeface="Calibri" pitchFamily="34" charset="-122"/>
+                          <a:cs typeface="Calibri" pitchFamily="34" charset="-120"/>
+                        </a:rPr>
+                        <a:t>Estimate</a:t>
+                      </a:r>
+                      <a:endParaRPr lang="en-US" sz="1100" dirty="0">
+                        <a:latin typeface="Calibri" charset="0"/>
+                        <a:ea typeface="Calibri" charset="0"/>
+                        <a:cs typeface="Calibri" charset="0"/>
+                      </a:endParaRPr>
+                    </a:p>
+                  </a:txBody>
+                  <a:tcPr marL="91440" marR="91440" marT="45720" marB="45720" anchor="ctr">
+                    <a:lnL w="6350" cap="flat" cmpd="sng" algn="ctr">
+                      <a:solidFill>
+                        <a:srgbClr val="DDDDDD"/>
+                      </a:solidFill>
+                      <a:prstDash val="solid"/>
+                      <a:round/>
+                      <a:headEnd type="none" w="med" len="med"/>
+                      <a:tailEnd type="none" w="med" len="med"/>
+                    </a:lnL>
+                    <a:lnR w="6350" cap="flat" cmpd="sng" algn="ctr">
+                      <a:solidFill>
+                        <a:srgbClr val="DDDDDD"/>
+                      </a:solidFill>
+                      <a:prstDash val="solid"/>
+                      <a:round/>
+                      <a:headEnd type="none" w="med" len="med"/>
+                      <a:tailEnd type="none" w="med" len="med"/>
+                    </a:lnR>
+                    <a:lnT w="6350" cap="flat" cmpd="sng" algn="ctr">
+                      <a:solidFill>
+                        <a:srgbClr val="DDDDDD"/>
+                      </a:solidFill>
+                      <a:prstDash val="solid"/>
+                      <a:round/>
+                      <a:headEnd type="none" w="med" len="med"/>
+                      <a:tailEnd type="none" w="med" len="med"/>
+                    </a:lnT>
+                    <a:lnB w="6350" cap="flat" cmpd="sng" algn="ctr">
+                      <a:solidFill>
+                        <a:srgbClr val="DDDDDD"/>
+                      </a:solidFill>
+                      <a:prstDash val="solid"/>
+                      <a:round/>
+                      <a:headEnd type="none" w="med" len="med"/>
+                      <a:tailEnd type="none" w="med" len="med"/>
+                    </a:lnB>
+                    <a:solidFill>
+                      <a:srgbClr val="4A7FB5"/>
+                    </a:solidFill>
+                  </a:tcPr>
+                </a:tc>
+                <a:tc>
+                  <a:txBody>
+                    <a:bodyPr/>
+                    <a:lstStyle/>
+                    <a:p>
+                      <a:pPr algn="ctr" indent="0" marL="0">
+                        <a:buNone/>
+                      </a:pPr>
+                      <a:r>
+                        <a:rPr lang="en-US" sz="1100" b="1" dirty="0">
+                          <a:solidFill>
+                            <a:srgbClr val="FFFFFF"/>
+                          </a:solidFill>
+                          <a:latin typeface="Calibri" pitchFamily="34" charset="0"/>
+                          <a:ea typeface="Calibri" pitchFamily="34" charset="-122"/>
+                          <a:cs typeface="Calibri" pitchFamily="34" charset="-120"/>
+                        </a:rPr>
+                        <a:t>t-stat</a:t>
+                      </a:r>
+                      <a:endParaRPr lang="en-US" sz="1100" dirty="0">
+                        <a:latin typeface="Calibri" charset="0"/>
+                        <a:ea typeface="Calibri" charset="0"/>
+                        <a:cs typeface="Calibri" charset="0"/>
+                      </a:endParaRPr>
+                    </a:p>
+                  </a:txBody>
+                  <a:tcPr marL="91440" marR="91440" marT="45720" marB="45720" anchor="ctr">
+                    <a:lnL w="6350" cap="flat" cmpd="sng" algn="ctr">
+                      <a:solidFill>
+                        <a:srgbClr val="DDDDDD"/>
+                      </a:solidFill>
+                      <a:prstDash val="solid"/>
+                      <a:round/>
+                      <a:headEnd type="none" w="med" len="med"/>
+                      <a:tailEnd type="none" w="med" len="med"/>
+                    </a:lnL>
+                    <a:lnR w="6350" cap="flat" cmpd="sng" algn="ctr">
+                      <a:solidFill>
+                        <a:srgbClr val="DDDDDD"/>
+                      </a:solidFill>
+                      <a:prstDash val="solid"/>
+                      <a:round/>
+                      <a:headEnd type="none" w="med" len="med"/>
+                      <a:tailEnd type="none" w="med" len="med"/>
+                    </a:lnR>
+                    <a:lnT w="6350" cap="flat" cmpd="sng" algn="ctr">
+                      <a:solidFill>
+                        <a:srgbClr val="DDDDDD"/>
+                      </a:solidFill>
+                      <a:prstDash val="solid"/>
+                      <a:round/>
+                      <a:headEnd type="none" w="med" len="med"/>
+                      <a:tailEnd type="none" w="med" len="med"/>
+                    </a:lnT>
+                    <a:lnB w="6350" cap="flat" cmpd="sng" algn="ctr">
+                      <a:solidFill>
+                        <a:srgbClr val="DDDDDD"/>
+                      </a:solidFill>
+                      <a:prstDash val="solid"/>
+                      <a:round/>
+                      <a:headEnd type="none" w="med" len="med"/>
+                      <a:tailEnd type="none" w="med" len="med"/>
+                    </a:lnB>
+                    <a:solidFill>
+                      <a:srgbClr val="4A7FB5"/>
+                    </a:solidFill>
+                  </a:tcPr>
+                </a:tc>
+              </a:tr>
+              <a:tr h="320040">
+                <a:tc>
+                  <a:txBody>
+                    <a:bodyPr/>
+                    <a:lstStyle/>
+                    <a:p>
+                      <a:pPr algn="ctr" indent="0" marL="0">
+                        <a:buNone/>
+                      </a:pPr>
+                      <a:r>
+                        <a:rPr lang="en-US" sz="1200" dirty="0">
+                          <a:solidFill>
+                            <a:srgbClr val="2D2D2D"/>
+                          </a:solidFill>
+                          <a:latin typeface="Calibri" pitchFamily="34" charset="0"/>
+                          <a:ea typeface="Calibri" pitchFamily="34" charset="-122"/>
+                          <a:cs typeface="Calibri" pitchFamily="34" charset="-120"/>
+                        </a:rPr>
+                        <a:t>α (semantic)</a:t>
+                      </a:r>
+                      <a:endParaRPr lang="en-US" sz="1200" dirty="0">
+                        <a:latin typeface="Calibri" charset="0"/>
+                        <a:ea typeface="Calibri" charset="0"/>
+                        <a:cs typeface="Calibri" charset="0"/>
+                      </a:endParaRPr>
+                    </a:p>
+                  </a:txBody>
+                  <a:tcPr marL="91440" marR="91440" marT="45720" marB="45720" anchor="ctr">
+                    <a:lnL w="6350" cap="flat" cmpd="sng" algn="ctr">
+                      <a:solidFill>
+                        <a:srgbClr val="DDDDDD"/>
+                      </a:solidFill>
+                      <a:prstDash val="solid"/>
+                      <a:round/>
+                      <a:headEnd type="none" w="med" len="med"/>
+                      <a:tailEnd type="none" w="med" len="med"/>
+                    </a:lnL>
+                    <a:lnR w="6350" cap="flat" cmpd="sng" algn="ctr">
+                      <a:solidFill>
+                        <a:srgbClr val="DDDDDD"/>
+                      </a:solidFill>
+                      <a:prstDash val="solid"/>
+                      <a:round/>
+                      <a:headEnd type="none" w="med" len="med"/>
+                      <a:tailEnd type="none" w="med" len="med"/>
+                    </a:lnR>
+                    <a:lnT w="6350" cap="flat" cmpd="sng" algn="ctr">
+                      <a:solidFill>
+                        <a:srgbClr val="DDDDDD"/>
+                      </a:solidFill>
+                      <a:prstDash val="solid"/>
+                      <a:round/>
+                      <a:headEnd type="none" w="med" len="med"/>
+                      <a:tailEnd type="none" w="med" len="med"/>
+                    </a:lnT>
+                    <a:lnB w="6350" cap="flat" cmpd="sng" algn="ctr">
+                      <a:solidFill>
+                        <a:srgbClr val="DDDDDD"/>
+                      </a:solidFill>
+                      <a:prstDash val="solid"/>
+                      <a:round/>
+                      <a:headEnd type="none" w="med" len="med"/>
+                      <a:tailEnd type="none" w="med" len="med"/>
+                    </a:lnB>
+                    <a:solidFill>
+                      <a:srgbClr val="F8F8F8"/>
+                    </a:solidFill>
+                  </a:tcPr>
+                </a:tc>
+                <a:tc>
+                  <a:txBody>
+                    <a:bodyPr/>
+                    <a:lstStyle/>
+                    <a:p>
+                      <a:pPr algn="ctr" indent="0" marL="0">
+                        <a:buNone/>
+                      </a:pPr>
+                      <a:r>
+                        <a:rPr lang="en-US" sz="1200" b="1" dirty="0">
+                          <a:solidFill>
+                            <a:srgbClr val="2D2D2D"/>
+                          </a:solidFill>
+                          <a:latin typeface="Calibri" pitchFamily="34" charset="0"/>
+                          <a:ea typeface="Calibri" pitchFamily="34" charset="-122"/>
+                          <a:cs typeface="Calibri" pitchFamily="34" charset="-120"/>
+                        </a:rPr>
+                        <a:t>7.404</a:t>
+                      </a:r>
+                      <a:endParaRPr lang="en-US" sz="1200" dirty="0">
+                        <a:latin typeface="Calibri" charset="0"/>
+                        <a:ea typeface="Calibri" charset="0"/>
+                        <a:cs typeface="Calibri" charset="0"/>
+                      </a:endParaRPr>
+                    </a:p>
+                  </a:txBody>
+                  <a:tcPr marL="91440" marR="91440" marT="45720" marB="45720" anchor="ctr">
+                    <a:lnL w="6350" cap="flat" cmpd="sng" algn="ctr">
+                      <a:solidFill>
+                        <a:srgbClr val="DDDDDD"/>
+                      </a:solidFill>
+                      <a:prstDash val="solid"/>
+                      <a:round/>
+                      <a:headEnd type="none" w="med" len="med"/>
+                      <a:tailEnd type="none" w="med" len="med"/>
+                    </a:lnL>
+                    <a:lnR w="6350" cap="flat" cmpd="sng" algn="ctr">
+                      <a:solidFill>
+                        <a:srgbClr val="DDDDDD"/>
+                      </a:solidFill>
+                      <a:prstDash val="solid"/>
+                      <a:round/>
+                      <a:headEnd type="none" w="med" len="med"/>
+                      <a:tailEnd type="none" w="med" len="med"/>
+                    </a:lnR>
+                    <a:lnT w="6350" cap="flat" cmpd="sng" algn="ctr">
+                      <a:solidFill>
+                        <a:srgbClr val="DDDDDD"/>
+                      </a:solidFill>
+                      <a:prstDash val="solid"/>
+                      <a:round/>
+                      <a:headEnd type="none" w="med" len="med"/>
+                      <a:tailEnd type="none" w="med" len="med"/>
+                    </a:lnT>
+                    <a:lnB w="6350" cap="flat" cmpd="sng" algn="ctr">
+                      <a:solidFill>
+                        <a:srgbClr val="DDDDDD"/>
+                      </a:solidFill>
+                      <a:prstDash val="solid"/>
+                      <a:round/>
+                      <a:headEnd type="none" w="med" len="med"/>
+                      <a:tailEnd type="none" w="med" len="med"/>
+                    </a:lnB>
+                    <a:solidFill>
+                      <a:srgbClr val="F8F8F8"/>
+                    </a:solidFill>
+                  </a:tcPr>
+                </a:tc>
+                <a:tc>
+                  <a:txBody>
+                    <a:bodyPr/>
+                    <a:lstStyle/>
+                    <a:p>
+                      <a:pPr algn="ctr" indent="0" marL="0">
+                        <a:buNone/>
+                      </a:pPr>
+                      <a:r>
+                        <a:rPr lang="en-US" sz="1200" dirty="0">
+                          <a:solidFill>
+                            <a:srgbClr val="2D2D2D"/>
+                          </a:solidFill>
+                          <a:latin typeface="Calibri" pitchFamily="34" charset="0"/>
+                          <a:ea typeface="Calibri" pitchFamily="34" charset="-122"/>
+                          <a:cs typeface="Calibri" pitchFamily="34" charset="-120"/>
+                        </a:rPr>
+                        <a:t>204.0</a:t>
+                      </a:r>
+                      <a:endParaRPr lang="en-US" sz="1200" dirty="0">
+                        <a:latin typeface="Calibri" charset="0"/>
+                        <a:ea typeface="Calibri" charset="0"/>
+                        <a:cs typeface="Calibri" charset="0"/>
+                      </a:endParaRPr>
+                    </a:p>
+                  </a:txBody>
+                  <a:tcPr marL="91440" marR="91440" marT="45720" marB="45720" anchor="ctr">
+                    <a:lnL w="6350" cap="flat" cmpd="sng" algn="ctr">
+                      <a:solidFill>
+                        <a:srgbClr val="DDDDDD"/>
+                      </a:solidFill>
+                      <a:prstDash val="solid"/>
+                      <a:round/>
+                      <a:headEnd type="none" w="med" len="med"/>
+                      <a:tailEnd type="none" w="med" len="med"/>
+                    </a:lnL>
+                    <a:lnR w="6350" cap="flat" cmpd="sng" algn="ctr">
+                      <a:solidFill>
+                        <a:srgbClr val="DDDDDD"/>
+                      </a:solidFill>
+                      <a:prstDash val="solid"/>
+                      <a:round/>
+                      <a:headEnd type="none" w="med" len="med"/>
+                      <a:tailEnd type="none" w="med" len="med"/>
+                    </a:lnR>
+                    <a:lnT w="6350" cap="flat" cmpd="sng" algn="ctr">
+                      <a:solidFill>
+                        <a:srgbClr val="DDDDDD"/>
+                      </a:solidFill>
+                      <a:prstDash val="solid"/>
+                      <a:round/>
+                      <a:headEnd type="none" w="med" len="med"/>
+                      <a:tailEnd type="none" w="med" len="med"/>
+                    </a:lnT>
+                    <a:lnB w="6350" cap="flat" cmpd="sng" algn="ctr">
+                      <a:solidFill>
+                        <a:srgbClr val="DDDDDD"/>
+                      </a:solidFill>
+                      <a:prstDash val="solid"/>
+                      <a:round/>
+                      <a:headEnd type="none" w="med" len="med"/>
+                      <a:tailEnd type="none" w="med" len="med"/>
+                    </a:lnB>
+                    <a:solidFill>
+                      <a:srgbClr val="F8F8F8"/>
+                    </a:solidFill>
+                  </a:tcPr>
+                </a:tc>
+              </a:tr>
+              <a:tr h="320040">
+                <a:tc>
+                  <a:txBody>
+                    <a:bodyPr/>
+                    <a:lstStyle/>
+                    <a:p>
+                      <a:pPr algn="ctr" indent="0" marL="0">
+                        <a:buNone/>
+                      </a:pPr>
+                      <a:r>
+                        <a:rPr lang="en-US" sz="1200" dirty="0">
+                          <a:solidFill>
+                            <a:srgbClr val="2D2D2D"/>
+                          </a:solidFill>
+                          <a:latin typeface="Calibri" pitchFamily="34" charset="0"/>
+                          <a:ea typeface="Calibri" pitchFamily="34" charset="-122"/>
+                          <a:cs typeface="Calibri" pitchFamily="34" charset="-120"/>
+                        </a:rPr>
+                        <a:t>β (institutional)</a:t>
+                      </a:r>
+                      <a:endParaRPr lang="en-US" sz="1200" dirty="0">
+                        <a:latin typeface="Calibri" charset="0"/>
+                        <a:ea typeface="Calibri" charset="0"/>
+                        <a:cs typeface="Calibri" charset="0"/>
+                      </a:endParaRPr>
+                    </a:p>
+                  </a:txBody>
+                  <a:tcPr marL="91440" marR="91440" marT="45720" marB="45720" anchor="ctr">
+                    <a:lnL w="6350" cap="flat" cmpd="sng" algn="ctr">
+                      <a:solidFill>
+                        <a:srgbClr val="DDDDDD"/>
+                      </a:solidFill>
+                      <a:prstDash val="solid"/>
+                      <a:round/>
+                      <a:headEnd type="none" w="med" len="med"/>
+                      <a:tailEnd type="none" w="med" len="med"/>
+                    </a:lnL>
+                    <a:lnR w="6350" cap="flat" cmpd="sng" algn="ctr">
+                      <a:solidFill>
+                        <a:srgbClr val="DDDDDD"/>
+                      </a:solidFill>
+                      <a:prstDash val="solid"/>
+                      <a:round/>
+                      <a:headEnd type="none" w="med" len="med"/>
+                      <a:tailEnd type="none" w="med" len="med"/>
+                    </a:lnR>
+                    <a:lnT w="6350" cap="flat" cmpd="sng" algn="ctr">
+                      <a:solidFill>
+                        <a:srgbClr val="DDDDDD"/>
+                      </a:solidFill>
+                      <a:prstDash val="solid"/>
+                      <a:round/>
+                      <a:headEnd type="none" w="med" len="med"/>
+                      <a:tailEnd type="none" w="med" len="med"/>
+                    </a:lnT>
+                    <a:lnB w="6350" cap="flat" cmpd="sng" algn="ctr">
+                      <a:solidFill>
+                        <a:srgbClr val="DDDDDD"/>
+                      </a:solidFill>
+                      <a:prstDash val="solid"/>
+                      <a:round/>
+                      <a:headEnd type="none" w="med" len="med"/>
+                      <a:tailEnd type="none" w="med" len="med"/>
+                    </a:lnB>
+                    <a:solidFill>
+                      <a:srgbClr val="F8F8F8"/>
+                    </a:solidFill>
+                  </a:tcPr>
+                </a:tc>
+                <a:tc>
+                  <a:txBody>
+                    <a:bodyPr/>
+                    <a:lstStyle/>
+                    <a:p>
+                      <a:pPr algn="ctr" indent="0" marL="0">
+                        <a:buNone/>
+                      </a:pPr>
+                      <a:r>
+                        <a:rPr lang="en-US" sz="1200" b="1" dirty="0">
+                          <a:solidFill>
+                            <a:srgbClr val="2D2D2D"/>
+                          </a:solidFill>
+                          <a:latin typeface="Calibri" pitchFamily="34" charset="0"/>
+                          <a:ea typeface="Calibri" pitchFamily="34" charset="-122"/>
+                          <a:cs typeface="Calibri" pitchFamily="34" charset="-120"/>
+                        </a:rPr>
+                        <a:t>0.139</a:t>
+                      </a:r>
+                      <a:endParaRPr lang="en-US" sz="1200" dirty="0">
+                        <a:latin typeface="Calibri" charset="0"/>
+                        <a:ea typeface="Calibri" charset="0"/>
+                        <a:cs typeface="Calibri" charset="0"/>
+                      </a:endParaRPr>
+                    </a:p>
+                  </a:txBody>
+                  <a:tcPr marL="91440" marR="91440" marT="45720" marB="45720" anchor="ctr">
+                    <a:lnL w="6350" cap="flat" cmpd="sng" algn="ctr">
+                      <a:solidFill>
+                        <a:srgbClr val="DDDDDD"/>
+                      </a:solidFill>
+                      <a:prstDash val="solid"/>
+                      <a:round/>
+                      <a:headEnd type="none" w="med" len="med"/>
+                      <a:tailEnd type="none" w="med" len="med"/>
+                    </a:lnL>
+                    <a:lnR w="6350" cap="flat" cmpd="sng" algn="ctr">
+                      <a:solidFill>
+                        <a:srgbClr val="DDDDDD"/>
+                      </a:solidFill>
+                      <a:prstDash val="solid"/>
+                      <a:round/>
+                      <a:headEnd type="none" w="med" len="med"/>
+                      <a:tailEnd type="none" w="med" len="med"/>
+                    </a:lnR>
+                    <a:lnT w="6350" cap="flat" cmpd="sng" algn="ctr">
+                      <a:solidFill>
+                        <a:srgbClr val="DDDDDD"/>
+                      </a:solidFill>
+                      <a:prstDash val="solid"/>
+                      <a:round/>
+                      <a:headEnd type="none" w="med" len="med"/>
+                      <a:tailEnd type="none" w="med" len="med"/>
+                    </a:lnT>
+                    <a:lnB w="6350" cap="flat" cmpd="sng" algn="ctr">
+                      <a:solidFill>
+                        <a:srgbClr val="DDDDDD"/>
+                      </a:solidFill>
+                      <a:prstDash val="solid"/>
+                      <a:round/>
+                      <a:headEnd type="none" w="med" len="med"/>
+                      <a:tailEnd type="none" w="med" len="med"/>
+                    </a:lnB>
+                    <a:solidFill>
+                      <a:srgbClr val="F8F8F8"/>
+                    </a:solidFill>
+                  </a:tcPr>
+                </a:tc>
+                <a:tc>
+                  <a:txBody>
+                    <a:bodyPr/>
+                    <a:lstStyle/>
+                    <a:p>
+                      <a:pPr algn="ctr" indent="0" marL="0">
+                        <a:buNone/>
+                      </a:pPr>
+                      <a:r>
+                        <a:rPr lang="en-US" sz="1200" dirty="0">
+                          <a:solidFill>
+                            <a:srgbClr val="2D2D2D"/>
+                          </a:solidFill>
+                          <a:latin typeface="Calibri" pitchFamily="34" charset="0"/>
+                          <a:ea typeface="Calibri" pitchFamily="34" charset="-122"/>
+                          <a:cs typeface="Calibri" pitchFamily="34" charset="-120"/>
+                        </a:rPr>
+                        <a:t>33.7</a:t>
+                      </a:r>
+                      <a:endParaRPr lang="en-US" sz="1200" dirty="0">
+                        <a:latin typeface="Calibri" charset="0"/>
+                        <a:ea typeface="Calibri" charset="0"/>
+                        <a:cs typeface="Calibri" charset="0"/>
+                      </a:endParaRPr>
+                    </a:p>
+                  </a:txBody>
+                  <a:tcPr marL="91440" marR="91440" marT="45720" marB="45720" anchor="ctr">
+                    <a:lnL w="6350" cap="flat" cmpd="sng" algn="ctr">
+                      <a:solidFill>
+                        <a:srgbClr val="DDDDDD"/>
+                      </a:solidFill>
+                      <a:prstDash val="solid"/>
+                      <a:round/>
+                      <a:headEnd type="none" w="med" len="med"/>
+                      <a:tailEnd type="none" w="med" len="med"/>
+                    </a:lnL>
+                    <a:lnR w="6350" cap="flat" cmpd="sng" algn="ctr">
+                      <a:solidFill>
+                        <a:srgbClr val="DDDDDD"/>
+                      </a:solidFill>
+                      <a:prstDash val="solid"/>
+                      <a:round/>
+                      <a:headEnd type="none" w="med" len="med"/>
+                      <a:tailEnd type="none" w="med" len="med"/>
+                    </a:lnR>
+                    <a:lnT w="6350" cap="flat" cmpd="sng" algn="ctr">
+                      <a:solidFill>
+                        <a:srgbClr val="DDDDDD"/>
+                      </a:solidFill>
+                      <a:prstDash val="solid"/>
+                      <a:round/>
+                      <a:headEnd type="none" w="med" len="med"/>
+                      <a:tailEnd type="none" w="med" len="med"/>
+                    </a:lnT>
+                    <a:lnB w="6350" cap="flat" cmpd="sng" algn="ctr">
+                      <a:solidFill>
+                        <a:srgbClr val="DDDDDD"/>
+                      </a:solidFill>
+                      <a:prstDash val="solid"/>
+                      <a:round/>
+                      <a:headEnd type="none" w="med" len="med"/>
+                      <a:tailEnd type="none" w="med" len="med"/>
+                    </a:lnB>
+                    <a:solidFill>
+                      <a:srgbClr val="F8F8F8"/>
+                    </a:solidFill>
+                  </a:tcPr>
+                </a:tc>
+              </a:tr>
+            </a:tbl>
+          </a:graphicData>
+        </a:graphic>
+      </p:graphicFrame>
+      <p:sp>
+        <p:nvSpPr>
+          <p:cNvPr id="8" name="Text 4"/>
+          <p:cNvSpPr/>
+          <p:nvPr/>
+        </p:nvSpPr>
+        <p:spPr>
+          <a:xfrm>
+            <a:off x="5669280" y="2651760"/>
+            <a:ext cx="3017520" cy="914400"/>
+          </a:xfrm>
+          <a:prstGeom prst="rect">
+            <a:avLst/>
+          </a:prstGeom>
+          <a:noFill/>
+          <a:ln/>
+        </p:spPr>
+        <p:txBody>
+          <a:bodyPr wrap="square" rtlCol="0" anchor="ctr"/>
+          <a:lstStyle/>
+          <a:p>
+            <a:pPr algn="ctr" indent="0" marL="0">
+              <a:lnSpc>
+                <a:spcPct val="140000"/>
+              </a:lnSpc>
+              <a:buNone/>
+            </a:pPr>
+            <a:r>
+              <a:rPr lang="en-US" sz="1100" dirty="0">
+                <a:solidFill>
+                  <a:srgbClr val="777777"/>
+                </a:solidFill>
+                <a:latin typeface="Calibri" pitchFamily="34" charset="0"/>
+                <a:ea typeface="Calibri" pitchFamily="34" charset="-122"/>
+                <a:cs typeface="Calibri" pitchFamily="34" charset="-120"/>
+              </a:rPr>
+              <a:t>N = 89,329 transitions</a:t>
+            </a:r>
+            <a:endParaRPr lang="en-US" sz="1100" dirty="0"/>
+          </a:p>
+          <a:p>
+            <a:pPr algn="ctr" indent="0" marL="0">
+              <a:lnSpc>
+                <a:spcPct val="140000"/>
+              </a:lnSpc>
+              <a:buNone/>
+            </a:pPr>
+            <a:r>
+              <a:rPr lang="en-US" sz="1100" dirty="0">
+                <a:solidFill>
+                  <a:srgbClr val="777777"/>
+                </a:solidFill>
+                <a:latin typeface="Calibri" pitchFamily="34" charset="0"/>
+                <a:ea typeface="Calibri" pitchFamily="34" charset="-122"/>
+                <a:cs typeface="Calibri" pitchFamily="34" charset="-120"/>
+              </a:rPr>
+              <a:t>Pseudo-R² = 14.08%</a:t>
+            </a:r>
+            <a:endParaRPr lang="en-US" sz="1100" dirty="0"/>
+          </a:p>
+          <a:p>
+            <a:pPr algn="ctr" indent="0" marL="0">
+              <a:lnSpc>
+                <a:spcPct val="140000"/>
+              </a:lnSpc>
+              <a:buNone/>
+            </a:pPr>
+            <a:r>
+              <a:rPr lang="en-US" sz="1100" dirty="0">
+                <a:solidFill>
+                  <a:srgbClr val="777777"/>
+                </a:solidFill>
+                <a:latin typeface="Calibri" pitchFamily="34" charset="0"/>
+                <a:ea typeface="Calibri" pitchFamily="34" charset="-122"/>
+                <a:cs typeface="Calibri" pitchFamily="34" charset="-120"/>
+              </a:rPr>
+              <a:t>Sampled alternatives (J = 11)</a:t>
+            </a:r>
+            <a:endParaRPr lang="en-US" sz="1100" dirty="0"/>
+          </a:p>
+        </p:txBody>
+      </p:sp>
+      <p:sp>
+        <p:nvSpPr>
+          <p:cNvPr id="9" name="Text 5"/>
+          <p:cNvSpPr/>
+          <p:nvPr/>
+        </p:nvSpPr>
+        <p:spPr>
+          <a:xfrm>
+            <a:off x="5669280" y="3474720"/>
+            <a:ext cx="3017520" cy="914400"/>
+          </a:xfrm>
+          <a:prstGeom prst="rect">
+            <a:avLst/>
+          </a:prstGeom>
+          <a:noFill/>
+          <a:ln/>
+        </p:spPr>
+        <p:txBody>
+          <a:bodyPr wrap="square" rtlCol="0" anchor="ctr"/>
+          <a:lstStyle/>
+          <a:p>
+            <a:pPr algn="ctr" indent="0" marL="0">
+              <a:lnSpc>
+                <a:spcPct val="130000"/>
+              </a:lnSpc>
+              <a:buNone/>
+            </a:pPr>
+            <a:r>
+              <a:rPr lang="en-US" sz="1100" i="1" dirty="0">
+                <a:solidFill>
+                  <a:srgbClr val="2D2D2D"/>
+                </a:solidFill>
+                <a:latin typeface="Calibri" pitchFamily="34" charset="0"/>
+                <a:ea typeface="Calibri" pitchFamily="34" charset="-122"/>
+                <a:cs typeface="Calibri" pitchFamily="34" charset="-120"/>
+              </a:rPr>
+              <a:t>Semantic distance dominates.</a:t>
+            </a:r>
+            <a:endParaRPr lang="en-US" sz="1100" dirty="0"/>
+          </a:p>
+          <a:p>
+            <a:pPr algn="ctr" indent="0" marL="0">
+              <a:lnSpc>
+                <a:spcPct val="130000"/>
+              </a:lnSpc>
+              <a:buNone/>
+            </a:pPr>
+            <a:r>
+              <a:rPr lang="en-US" sz="1100" i="1" dirty="0">
+                <a:solidFill>
+                  <a:srgbClr val="2D2D2D"/>
+                </a:solidFill>
+                <a:latin typeface="Calibri" pitchFamily="34" charset="0"/>
+                <a:ea typeface="Calibri" pitchFamily="34" charset="-122"/>
+                <a:cs typeface="Calibri" pitchFamily="34" charset="-120"/>
+              </a:rPr>
+              <a:t>Institutional barriers add</a:t>
+            </a:r>
+            <a:endParaRPr lang="en-US" sz="1100" dirty="0"/>
+          </a:p>
+          <a:p>
+            <a:pPr algn="ctr" indent="0" marL="0">
+              <a:lnSpc>
+                <a:spcPct val="130000"/>
+              </a:lnSpc>
+              <a:buNone/>
+            </a:pPr>
+            <a:r>
+              <a:rPr lang="en-US" sz="1100" i="1" dirty="0">
+                <a:solidFill>
+                  <a:srgbClr val="2D2D2D"/>
+                </a:solidFill>
+                <a:latin typeface="Calibri" pitchFamily="34" charset="0"/>
+                <a:ea typeface="Calibri" pitchFamily="34" charset="-122"/>
+                <a:cs typeface="Calibri" pitchFamily="34" charset="-120"/>
+              </a:rPr>
+              <a:t>independent predictive power.</a:t>
+            </a:r>
+            <a:endParaRPr lang="en-US" sz="1100" dirty="0"/>
+          </a:p>
+        </p:txBody>
+      </p:sp>
     </p:spTree>
   </p:cSld>
   <p:clrMapOvr>

</xml_diff>

<commit_message>
v0.7.12.16: Presentation fixes — bar order, LaTeX eq, fig2 aspect ratio
Co-Authored-By: Claude Opus 4.6 <noreply@anthropic.com>
</commit_message>
<xml_diff>
--- a/writing/presentation/task_embeddings_deck.pptx
+++ b/writing/presentation/task_embeddings_deck.pptx
@@ -2845,7 +2845,7 @@
         <p:spPr>
           <a:xfrm>
             <a:off x="457200" y="1005840"/>
-            <a:ext cx="2743200" cy="3657600"/>
+            <a:ext cx="2011680" cy="3657600"/>
           </a:xfrm>
           <a:prstGeom prst="rect">
             <a:avLst/>
@@ -2952,8 +2952,8 @@
         </p:blipFill>
         <p:spPr>
           <a:xfrm>
-            <a:off x="3474720" y="822960"/>
-            <a:ext cx="4937760" cy="3657600"/>
+            <a:off x="2743200" y="822960"/>
+            <a:ext cx="5669280" cy="3657600"/>
           </a:xfrm>
           <a:prstGeom prst="rect">
             <a:avLst/>
@@ -4389,54 +4389,39 @@
           </a:graphicData>
         </a:graphic>
       </p:graphicFrame>
-      <p:sp>
-        <p:nvSpPr>
-          <p:cNvPr id="7" name="Text 4"/>
-          <p:cNvSpPr/>
+      <p:pic>
+        <p:nvPicPr>
+          <p:cNvPr id="7" name="Image 0" descr="../../figures/fig_logit_eq.png">    </p:cNvPr>
+          <p:cNvPicPr>
+            <a:picLocks noChangeAspect="1"/>
+          </p:cNvPicPr>
           <p:nvPr/>
-        </p:nvSpPr>
+        </p:nvPicPr>
+        <p:blipFill>
+          <a:blip r:embed="rId1"/>
+          <a:stretch>
+            <a:fillRect/>
+          </a:stretch>
+        </p:blipFill>
         <p:spPr>
           <a:xfrm>
-            <a:off x="914400" y="3108960"/>
-            <a:ext cx="7315200" cy="457200"/>
+            <a:off x="1371600" y="3291840"/>
+            <a:ext cx="6400800" cy="457200"/>
           </a:xfrm>
           <a:prstGeom prst="rect">
             <a:avLst/>
           </a:prstGeom>
-          <a:noFill/>
-          <a:ln/>
         </p:spPr>
-        <p:txBody>
-          <a:bodyPr wrap="square" rtlCol="0" anchor="ctr"/>
-          <a:lstStyle/>
-          <a:p>
-            <a:pPr algn="ctr" indent="0" marL="0">
-              <a:buNone/>
-            </a:pPr>
-            <a:r>
-              <a:rPr lang="en-US" sz="1600" dirty="0">
-                <a:solidFill>
-                  <a:srgbClr val="2D2D2D"/>
-                </a:solidFill>
-                <a:latin typeface="Courier New" pitchFamily="34" charset="0"/>
-                <a:ea typeface="Courier New" pitchFamily="34" charset="-122"/>
-                <a:cs typeface="Courier New" pitchFamily="34" charset="-120"/>
-              </a:rPr>
-              <a:t>P(j | i)  ∝  exp( −α · d_sem(i,j)  −  β · d_inst(i,j) )</a:t>
-            </a:r>
-            <a:endParaRPr lang="en-US" sz="1600" dirty="0"/>
-          </a:p>
-        </p:txBody>
-      </p:sp>
-      <p:sp>
-        <p:nvSpPr>
-          <p:cNvPr id="8" name="Text 5"/>
+      </p:pic>
+      <p:sp>
+        <p:nvSpPr>
+          <p:cNvPr id="8" name="Text 4"/>
           <p:cNvSpPr/>
           <p:nvPr/>
         </p:nvSpPr>
         <p:spPr>
           <a:xfrm>
-            <a:off x="457200" y="3657600"/>
+            <a:off x="457200" y="4114800"/>
             <a:ext cx="8229600" cy="457200"/>
           </a:xfrm>
           <a:prstGeom prst="rect">

</xml_diff>

<commit_message>
v0.7.12.17: Presentation fix pass 2 — aspect ratios, CM equation, bracket padding
Co-Authored-By: Claude Opus 4.6 <noreply@anthropic.com>
</commit_message>
<xml_diff>
--- a/writing/presentation/task_embeddings_deck.pptx
+++ b/writing/presentation/task_embeddings_deck.pptx
@@ -2930,7 +2930,7 @@
                 <a:ea typeface="Calibri" pitchFamily="34" charset="-122"/>
                 <a:cs typeface="Calibri" pitchFamily="34" charset="-120"/>
               </a:rPr>
-              <a:t>We propose a way to answer that question — and a test for whether it works.</a:t>
+              <a:t>We propose a way to answer that question, and a test for whether it works.</a:t>
             </a:r>
             <a:endParaRPr lang="en-US" sz="1400" dirty="0"/>
           </a:p>
@@ -2952,8 +2952,8 @@
         </p:blipFill>
         <p:spPr>
           <a:xfrm>
-            <a:off x="2743200" y="822960"/>
-            <a:ext cx="5669280" cy="3657600"/>
+            <a:off x="3017520" y="822960"/>
+            <a:ext cx="5029200" cy="3657600"/>
           </a:xfrm>
           <a:prstGeom prst="rect">
             <a:avLst/>
@@ -4405,8 +4405,8 @@
         </p:blipFill>
         <p:spPr>
           <a:xfrm>
-            <a:off x="1371600" y="3291840"/>
-            <a:ext cx="6400800" cy="457200"/>
+            <a:off x="1828800" y="3291840"/>
+            <a:ext cx="5486400" cy="804672"/>
           </a:xfrm>
           <a:prstGeom prst="rect">
             <a:avLst/>
@@ -4421,7 +4421,7 @@
         </p:nvSpPr>
         <p:spPr>
           <a:xfrm>
-            <a:off x="457200" y="4114800"/>
+            <a:off x="457200" y="4206240"/>
             <a:ext cx="8229600" cy="457200"/>
           </a:xfrm>
           <a:prstGeom prst="rect">
@@ -4446,7 +4446,7 @@
                 <a:ea typeface="Calibri" pitchFamily="34" charset="-122"/>
                 <a:cs typeface="Calibri" pitchFamily="34" charset="-120"/>
               </a:rPr>
-              <a:t>Validation: 89,329 verified transitions from the CPS. Primary metric: McFadden’s pseudo-R².</a:t>
+              <a:t>Conditional logit: each worker chooses among destinations weighted by semantic task similarity (α) and institutional proximity (β).</a:t>
             </a:r>
             <a:endParaRPr lang="en-US" sz="1400" dirty="0"/>
           </a:p>

</xml_diff>

<commit_message>
v0.7.12.18: Presentation fix 3 — layout, two-line labels, right panel centered
Co-Authored-By: Claude Opus 4.6 <noreply@anthropic.com>
</commit_message>
<xml_diff>
--- a/writing/presentation/task_embeddings_deck.pptx
+++ b/writing/presentation/task_embeddings_deck.pptx
@@ -2845,7 +2845,7 @@
         <p:spPr>
           <a:xfrm>
             <a:off x="457200" y="1005840"/>
-            <a:ext cx="2011680" cy="3657600"/>
+            <a:ext cx="2743200" cy="3657600"/>
           </a:xfrm>
           <a:prstGeom prst="rect">
             <a:avLst/>
@@ -2952,7 +2952,7 @@
         </p:blipFill>
         <p:spPr>
           <a:xfrm>
-            <a:off x="3017520" y="822960"/>
+            <a:off x="3474720" y="822960"/>
             <a:ext cx="5029200" cy="3657600"/>
           </a:xfrm>
           <a:prstGeom prst="rect">
@@ -4617,7 +4617,7 @@
         </p:nvSpPr>
         <p:spPr>
           <a:xfrm>
-            <a:off x="5669280" y="1005840"/>
+            <a:off x="5669280" y="1828800"/>
             <a:ext cx="3017520" cy="365760"/>
           </a:xfrm>
           <a:prstGeom prst="rect">
@@ -4663,7 +4663,7 @@
           </p:nvPr>
         </p:nvGraphicFramePr>
         <p:xfrm>
-          <a:off x="5669280" y="1463040"/>
+          <a:off x="5669280" y="2286000"/>
           <a:ext cx="3017520" cy="1097280"/>
         </p:xfrm>
         <a:graphic>
@@ -5305,7 +5305,7 @@
         </p:nvSpPr>
         <p:spPr>
           <a:xfrm>
-            <a:off x="5669280" y="2651760"/>
+            <a:off x="5669280" y="3474720"/>
             <a:ext cx="3017520" cy="914400"/>
           </a:xfrm>
           <a:prstGeom prst="rect">
@@ -5374,88 +5374,6 @@
                 <a:cs typeface="Calibri" pitchFamily="34" charset="-120"/>
               </a:rPr>
               <a:t>Sampled alternatives (J = 11)</a:t>
-            </a:r>
-            <a:endParaRPr lang="en-US" sz="1100" dirty="0"/>
-          </a:p>
-        </p:txBody>
-      </p:sp>
-      <p:sp>
-        <p:nvSpPr>
-          <p:cNvPr id="9" name="Text 5"/>
-          <p:cNvSpPr/>
-          <p:nvPr/>
-        </p:nvSpPr>
-        <p:spPr>
-          <a:xfrm>
-            <a:off x="5669280" y="3474720"/>
-            <a:ext cx="3017520" cy="914400"/>
-          </a:xfrm>
-          <a:prstGeom prst="rect">
-            <a:avLst/>
-          </a:prstGeom>
-          <a:noFill/>
-          <a:ln/>
-        </p:spPr>
-        <p:txBody>
-          <a:bodyPr wrap="square" rtlCol="0" anchor="ctr"/>
-          <a:lstStyle/>
-          <a:p>
-            <a:pPr algn="ctr" indent="0" marL="0">
-              <a:lnSpc>
-                <a:spcPct val="130000"/>
-              </a:lnSpc>
-              <a:buNone/>
-            </a:pPr>
-            <a:r>
-              <a:rPr lang="en-US" sz="1100" i="1" dirty="0">
-                <a:solidFill>
-                  <a:srgbClr val="2D2D2D"/>
-                </a:solidFill>
-                <a:latin typeface="Calibri" pitchFamily="34" charset="0"/>
-                <a:ea typeface="Calibri" pitchFamily="34" charset="-122"/>
-                <a:cs typeface="Calibri" pitchFamily="34" charset="-120"/>
-              </a:rPr>
-              <a:t>Semantic distance dominates.</a:t>
-            </a:r>
-            <a:endParaRPr lang="en-US" sz="1100" dirty="0"/>
-          </a:p>
-          <a:p>
-            <a:pPr algn="ctr" indent="0" marL="0">
-              <a:lnSpc>
-                <a:spcPct val="130000"/>
-              </a:lnSpc>
-              <a:buNone/>
-            </a:pPr>
-            <a:r>
-              <a:rPr lang="en-US" sz="1100" i="1" dirty="0">
-                <a:solidFill>
-                  <a:srgbClr val="2D2D2D"/>
-                </a:solidFill>
-                <a:latin typeface="Calibri" pitchFamily="34" charset="0"/>
-                <a:ea typeface="Calibri" pitchFamily="34" charset="-122"/>
-                <a:cs typeface="Calibri" pitchFamily="34" charset="-120"/>
-              </a:rPr>
-              <a:t>Institutional barriers add</a:t>
-            </a:r>
-            <a:endParaRPr lang="en-US" sz="1100" dirty="0"/>
-          </a:p>
-          <a:p>
-            <a:pPr algn="ctr" indent="0" marL="0">
-              <a:lnSpc>
-                <a:spcPct val="130000"/>
-              </a:lnSpc>
-              <a:buNone/>
-            </a:pPr>
-            <a:r>
-              <a:rPr lang="en-US" sz="1100" i="1" dirty="0">
-                <a:solidFill>
-                  <a:srgbClr val="2D2D2D"/>
-                </a:solidFill>
-                <a:latin typeface="Calibri" pitchFamily="34" charset="0"/>
-                <a:ea typeface="Calibri" pitchFamily="34" charset="-122"/>
-                <a:cs typeface="Calibri" pitchFamily="34" charset="-120"/>
-              </a:rPr>
-              <a:t>independent predictive power.</a:t>
             </a:r>
             <a:endParaRPr lang="en-US" sz="1100" dirty="0"/>
           </a:p>

</xml_diff>

<commit_message>
v0.7.12.19: Slide 8 layout — widen text, reposition scope chart
Co-Authored-By: Claude Opus 4.6 <noreply@anthropic.com>
</commit_message>
<xml_diff>
--- a/writing/presentation/task_embeddings_deck.pptx
+++ b/writing/presentation/task_embeddings_deck.pptx
@@ -5521,7 +5521,7 @@
         <p:spPr>
           <a:xfrm>
             <a:off x="457200" y="1005840"/>
-            <a:ext cx="3200400" cy="3657600"/>
+            <a:ext cx="3840480" cy="3657600"/>
           </a:xfrm>
           <a:prstGeom prst="rect">
             <a:avLst/>
@@ -5657,8 +5657,8 @@
         </p:blipFill>
         <p:spPr>
           <a:xfrm>
-            <a:off x="4114800" y="914400"/>
-            <a:ext cx="4480560" cy="3657600"/>
+            <a:off x="4572000" y="1097280"/>
+            <a:ext cx="3931920" cy="3200400"/>
           </a:xfrm>
           <a:prstGeom prst="rect">
             <a:avLst/>

</xml_diff>

<commit_message>
v0.7.12.20: Slide 9 — Future Pathways with validated core + research extensions
Co-Authored-By: Claude Opus 4.6 <noreply@anthropic.com>
</commit_message>
<xml_diff>
--- a/writing/presentation/task_embeddings_deck.pptx
+++ b/writing/presentation/task_embeddings_deck.pptx
@@ -5753,7 +5753,7 @@
                 <a:ea typeface="Calibri" pitchFamily="34" charset="-122"/>
                 <a:cs typeface="Calibri" pitchFamily="34" charset="-120"/>
               </a:rPr>
-              <a:t>Limitations and Scope</a:t>
+              <a:t>Future Pathways</a:t>
             </a:r>
             <a:endParaRPr lang="en-US" sz="2800" dirty="0"/>
           </a:p>
@@ -5806,8 +5806,8 @@
         </p:nvSpPr>
         <p:spPr>
           <a:xfrm>
-            <a:off x="457200" y="1005840"/>
-            <a:ext cx="8229600" cy="3657600"/>
+            <a:off x="457200" y="1097280"/>
+            <a:ext cx="2377440" cy="365760"/>
           </a:xfrm>
           <a:prstGeom prst="rect">
             <a:avLst/>
@@ -5816,17 +5816,14 @@
           <a:ln/>
         </p:spPr>
         <p:txBody>
-          <a:bodyPr wrap="square" rtlCol="0" anchor="t"/>
-          <a:lstStyle/>
-          <a:p>
-            <a:pPr indent="0" marL="0">
-              <a:lnSpc>
-                <a:spcPct val="130000"/>
-              </a:lnSpc>
-              <a:buNone/>
-            </a:pPr>
-            <a:r>
-              <a:rPr lang="en-US" sz="1400" dirty="0">
+          <a:bodyPr wrap="square" rtlCol="0" anchor="ctr"/>
+          <a:lstStyle/>
+          <a:p>
+            <a:pPr algn="ctr" indent="0" marL="0">
+              <a:buNone/>
+            </a:pPr>
+            <a:r>
+              <a:rPr lang="en-US" sz="1400" b="1" dirty="0">
                 <a:solidFill>
                   <a:srgbClr val="2D2D2D"/>
                 </a:solidFill>
@@ -5834,28 +5831,65 @@
                 <a:ea typeface="Calibri" pitchFamily="34" charset="-122"/>
                 <a:cs typeface="Calibri" pitchFamily="34" charset="-120"/>
               </a:rPr>
-              <a:t>Completed transitions only — workers blocked by licensing are absent.</a:t>
+              <a:t>This Paper</a:t>
             </a:r>
             <a:endParaRPr lang="en-US" sz="1400" dirty="0"/>
           </a:p>
-          <a:p>
-            <a:pPr indent="0" marL="0">
-              <a:lnSpc>
-                <a:spcPct val="130000"/>
-              </a:lnSpc>
-              <a:buNone/>
-            </a:pPr>
-            <a:endParaRPr lang="en-US" sz="1400" dirty="0"/>
-          </a:p>
-          <a:p>
-            <a:pPr indent="0" marL="0">
-              <a:lnSpc>
-                <a:spcPct val="130000"/>
-              </a:lnSpc>
-              <a:buNone/>
-            </a:pPr>
-            <a:r>
-              <a:rPr lang="en-US" sz="1400" dirty="0">
+        </p:txBody>
+      </p:sp>
+      <p:sp>
+        <p:nvSpPr>
+          <p:cNvPr id="6" name="Shape 4"/>
+          <p:cNvSpPr/>
+          <p:nvPr/>
+        </p:nvSpPr>
+        <p:spPr>
+          <a:xfrm>
+            <a:off x="457200" y="1645920"/>
+            <a:ext cx="2377440" cy="685800"/>
+          </a:xfrm>
+          <a:prstGeom prst="roundRect">
+            <a:avLst>
+              <a:gd name="adj" fmla="val 10667"/>
+            </a:avLst>
+          </a:prstGeom>
+          <a:solidFill>
+            <a:srgbClr val="E8F0F8"/>
+          </a:solidFill>
+          <a:ln w="15240">
+            <a:solidFill>
+              <a:srgbClr val="4A7FB5"/>
+            </a:solidFill>
+            <a:prstDash val="solid"/>
+          </a:ln>
+        </p:spPr>
+      </p:sp>
+      <p:sp>
+        <p:nvSpPr>
+          <p:cNvPr id="7" name="Text 5"/>
+          <p:cNvSpPr/>
+          <p:nvPr/>
+        </p:nvSpPr>
+        <p:spPr>
+          <a:xfrm>
+            <a:off x="457200" y="1691640"/>
+            <a:ext cx="2377440" cy="365760"/>
+          </a:xfrm>
+          <a:prstGeom prst="rect">
+            <a:avLst/>
+          </a:prstGeom>
+          <a:noFill/>
+          <a:ln/>
+        </p:spPr>
+        <p:txBody>
+          <a:bodyPr wrap="square" rtlCol="0" anchor="ctr"/>
+          <a:lstStyle/>
+          <a:p>
+            <a:pPr algn="ctr" indent="0" marL="0">
+              <a:buNone/>
+            </a:pPr>
+            <a:r>
+              <a:rPr lang="en-US" sz="1100" b="1" dirty="0">
                 <a:solidFill>
                   <a:srgbClr val="2D2D2D"/>
                 </a:solidFill>
@@ -5863,28 +5897,104 @@
                 <a:ea typeface="Calibri" pitchFamily="34" charset="-122"/>
                 <a:cs typeface="Calibri" pitchFamily="34" charset="-120"/>
               </a:rPr>
-              <a:t>Single embedding model (MPNet). Domain-specific models could differ.</a:t>
-            </a:r>
-            <a:endParaRPr lang="en-US" sz="1400" dirty="0"/>
-          </a:p>
-          <a:p>
-            <a:pPr indent="0" marL="0">
-              <a:lnSpc>
-                <a:spcPct val="130000"/>
-              </a:lnSpc>
-              <a:buNone/>
-            </a:pPr>
-            <a:endParaRPr lang="en-US" sz="1400" dirty="0"/>
-          </a:p>
-          <a:p>
-            <a:pPr indent="0" marL="0">
-              <a:lnSpc>
-                <a:spcPct val="130000"/>
-              </a:lnSpc>
-              <a:buNone/>
-            </a:pPr>
-            <a:r>
-              <a:rPr lang="en-US" sz="1400" dirty="0">
+              <a:t>Embedding distance</a:t>
+            </a:r>
+            <a:endParaRPr lang="en-US" sz="1100" dirty="0"/>
+          </a:p>
+        </p:txBody>
+      </p:sp>
+      <p:sp>
+        <p:nvSpPr>
+          <p:cNvPr id="8" name="Text 6"/>
+          <p:cNvSpPr/>
+          <p:nvPr/>
+        </p:nvSpPr>
+        <p:spPr>
+          <a:xfrm>
+            <a:off x="457200" y="1993392"/>
+            <a:ext cx="2377440" cy="274320"/>
+          </a:xfrm>
+          <a:prstGeom prst="rect">
+            <a:avLst/>
+          </a:prstGeom>
+          <a:noFill/>
+          <a:ln/>
+        </p:spPr>
+        <p:txBody>
+          <a:bodyPr wrap="square" rtlCol="0" anchor="ctr"/>
+          <a:lstStyle/>
+          <a:p>
+            <a:pPr algn="ctr" indent="0" marL="0">
+              <a:buNone/>
+            </a:pPr>
+            <a:r>
+              <a:rPr lang="en-US" sz="1000" dirty="0">
+                <a:solidFill>
+                  <a:srgbClr val="777777"/>
+                </a:solidFill>
+                <a:latin typeface="Calibri" pitchFamily="34" charset="0"/>
+                <a:ea typeface="Calibri" pitchFamily="34" charset="-122"/>
+                <a:cs typeface="Calibri" pitchFamily="34" charset="-120"/>
+              </a:rPr>
+              <a:t>pseudo-R² = 14.1%</a:t>
+            </a:r>
+            <a:endParaRPr lang="en-US" sz="1000" dirty="0"/>
+          </a:p>
+        </p:txBody>
+      </p:sp>
+      <p:sp>
+        <p:nvSpPr>
+          <p:cNvPr id="9" name="Shape 7"/>
+          <p:cNvSpPr/>
+          <p:nvPr/>
+        </p:nvSpPr>
+        <p:spPr>
+          <a:xfrm>
+            <a:off x="457200" y="2560320"/>
+            <a:ext cx="2377440" cy="685800"/>
+          </a:xfrm>
+          <a:prstGeom prst="roundRect">
+            <a:avLst>
+              <a:gd name="adj" fmla="val 10667"/>
+            </a:avLst>
+          </a:prstGeom>
+          <a:solidFill>
+            <a:srgbClr val="E8F0F8"/>
+          </a:solidFill>
+          <a:ln w="15240">
+            <a:solidFill>
+              <a:srgbClr val="4A7FB5"/>
+            </a:solidFill>
+            <a:prstDash val="solid"/>
+          </a:ln>
+        </p:spPr>
+      </p:sp>
+      <p:sp>
+        <p:nvSpPr>
+          <p:cNvPr id="10" name="Text 8"/>
+          <p:cNvSpPr/>
+          <p:nvPr/>
+        </p:nvSpPr>
+        <p:spPr>
+          <a:xfrm>
+            <a:off x="457200" y="2606040"/>
+            <a:ext cx="2377440" cy="365760"/>
+          </a:xfrm>
+          <a:prstGeom prst="rect">
+            <a:avLst/>
+          </a:prstGeom>
+          <a:noFill/>
+          <a:ln/>
+        </p:spPr>
+        <p:txBody>
+          <a:bodyPr wrap="square" rtlCol="0" anchor="ctr"/>
+          <a:lstStyle/>
+          <a:p>
+            <a:pPr algn="ctr" indent="0" marL="0">
+              <a:buNone/>
+            </a:pPr>
+            <a:r>
+              <a:rPr lang="en-US" sz="1100" b="1" dirty="0">
                 <a:solidFill>
                   <a:srgbClr val="2D2D2D"/>
                 </a:solidFill>
@@ -5892,28 +6002,104 @@
                 <a:ea typeface="Calibri" pitchFamily="34" charset="-122"/>
                 <a:cs typeface="Calibri" pitchFamily="34" charset="-120"/>
               </a:rPr>
-              <a:t>Cross-sectional — task content treated as static.</a:t>
-            </a:r>
-            <a:endParaRPr lang="en-US" sz="1400" dirty="0"/>
-          </a:p>
-          <a:p>
-            <a:pPr indent="0" marL="0">
-              <a:lnSpc>
-                <a:spcPct val="130000"/>
-              </a:lnSpc>
-              <a:buNone/>
-            </a:pPr>
-            <a:endParaRPr lang="en-US" sz="1400" dirty="0"/>
-          </a:p>
-          <a:p>
-            <a:pPr indent="0" marL="0">
-              <a:lnSpc>
-                <a:spcPct val="130000"/>
-              </a:lnSpc>
-              <a:buNone/>
-            </a:pPr>
-            <a:r>
-              <a:rPr lang="en-US" sz="1400" dirty="0">
+              <a:t>Institutional barriers</a:t>
+            </a:r>
+            <a:endParaRPr lang="en-US" sz="1100" dirty="0"/>
+          </a:p>
+        </p:txBody>
+      </p:sp>
+      <p:sp>
+        <p:nvSpPr>
+          <p:cNvPr id="11" name="Text 9"/>
+          <p:cNvSpPr/>
+          <p:nvPr/>
+        </p:nvSpPr>
+        <p:spPr>
+          <a:xfrm>
+            <a:off x="457200" y="2907792"/>
+            <a:ext cx="2377440" cy="274320"/>
+          </a:xfrm>
+          <a:prstGeom prst="rect">
+            <a:avLst/>
+          </a:prstGeom>
+          <a:noFill/>
+          <a:ln/>
+        </p:spPr>
+        <p:txBody>
+          <a:bodyPr wrap="square" rtlCol="0" anchor="ctr"/>
+          <a:lstStyle/>
+          <a:p>
+            <a:pPr algn="ctr" indent="0" marL="0">
+              <a:buNone/>
+            </a:pPr>
+            <a:r>
+              <a:rPr lang="en-US" sz="1000" dirty="0">
+                <a:solidFill>
+                  <a:srgbClr val="777777"/>
+                </a:solidFill>
+                <a:latin typeface="Calibri" pitchFamily="34" charset="0"/>
+                <a:ea typeface="Calibri" pitchFamily="34" charset="-122"/>
+                <a:cs typeface="Calibri" pitchFamily="34" charset="-120"/>
+              </a:rPr>
+              <a:t>t = 33.7</a:t>
+            </a:r>
+            <a:endParaRPr lang="en-US" sz="1000" dirty="0"/>
+          </a:p>
+        </p:txBody>
+      </p:sp>
+      <p:sp>
+        <p:nvSpPr>
+          <p:cNvPr id="12" name="Shape 10"/>
+          <p:cNvSpPr/>
+          <p:nvPr/>
+        </p:nvSpPr>
+        <p:spPr>
+          <a:xfrm>
+            <a:off x="457200" y="3474720"/>
+            <a:ext cx="2377440" cy="685800"/>
+          </a:xfrm>
+          <a:prstGeom prst="roundRect">
+            <a:avLst>
+              <a:gd name="adj" fmla="val 10667"/>
+            </a:avLst>
+          </a:prstGeom>
+          <a:solidFill>
+            <a:srgbClr val="E8F0F8"/>
+          </a:solidFill>
+          <a:ln w="15240">
+            <a:solidFill>
+              <a:srgbClr val="4A7FB5"/>
+            </a:solidFill>
+            <a:prstDash val="solid"/>
+          </a:ln>
+        </p:spPr>
+      </p:sp>
+      <p:sp>
+        <p:nvSpPr>
+          <p:cNvPr id="13" name="Text 11"/>
+          <p:cNvSpPr/>
+          <p:nvPr/>
+        </p:nvSpPr>
+        <p:spPr>
+          <a:xfrm>
+            <a:off x="457200" y="3520440"/>
+            <a:ext cx="2377440" cy="365760"/>
+          </a:xfrm>
+          <a:prstGeom prst="rect">
+            <a:avLst/>
+          </a:prstGeom>
+          <a:noFill/>
+          <a:ln/>
+        </p:spPr>
+        <p:txBody>
+          <a:bodyPr wrap="square" rtlCol="0" anchor="ctr"/>
+          <a:lstStyle/>
+          <a:p>
+            <a:pPr algn="ctr" indent="0" marL="0">
+              <a:buNone/>
+            </a:pPr>
+            <a:r>
+              <a:rPr lang="en-US" sz="1100" b="1" dirty="0">
                 <a:solidFill>
                   <a:srgbClr val="2D2D2D"/>
                 </a:solidFill>
@@ -5921,9 +6107,623 @@
                 <a:ea typeface="Calibri" pitchFamily="34" charset="-122"/>
                 <a:cs typeface="Calibri" pitchFamily="34" charset="-120"/>
               </a:rPr>
-              <a:t>Reallocation forecasts need vacancy, wage, geographic, and institutional data.</a:t>
+              <a:t>Stable across COVID</a:t>
+            </a:r>
+            <a:endParaRPr lang="en-US" sz="1100" dirty="0"/>
+          </a:p>
+        </p:txBody>
+      </p:sp>
+      <p:sp>
+        <p:nvSpPr>
+          <p:cNvPr id="14" name="Text 12"/>
+          <p:cNvSpPr/>
+          <p:nvPr/>
+        </p:nvSpPr>
+        <p:spPr>
+          <a:xfrm>
+            <a:off x="457200" y="3822192"/>
+            <a:ext cx="2377440" cy="274320"/>
+          </a:xfrm>
+          <a:prstGeom prst="rect">
+            <a:avLst/>
+          </a:prstGeom>
+          <a:noFill/>
+          <a:ln/>
+        </p:spPr>
+        <p:txBody>
+          <a:bodyPr wrap="square" rtlCol="0" anchor="ctr"/>
+          <a:lstStyle/>
+          <a:p>
+            <a:pPr algn="ctr" indent="0" marL="0">
+              <a:buNone/>
+            </a:pPr>
+            <a:r>
+              <a:rPr lang="en-US" sz="1000" dirty="0">
+                <a:solidFill>
+                  <a:srgbClr val="777777"/>
+                </a:solidFill>
+                <a:latin typeface="Calibri" pitchFamily="34" charset="0"/>
+                <a:ea typeface="Calibri" pitchFamily="34" charset="-122"/>
+                <a:cs typeface="Calibri" pitchFamily="34" charset="-120"/>
+              </a:rPr>
+              <a:t>p = 0.72</a:t>
+            </a:r>
+            <a:endParaRPr lang="en-US" sz="1000" dirty="0"/>
+          </a:p>
+        </p:txBody>
+      </p:sp>
+      <p:sp>
+        <p:nvSpPr>
+          <p:cNvPr id="15" name="Shape 13"/>
+          <p:cNvSpPr/>
+          <p:nvPr/>
+        </p:nvSpPr>
+        <p:spPr>
+          <a:xfrm>
+            <a:off x="2926080" y="2514600"/>
+            <a:ext cx="548640" cy="0"/>
+          </a:xfrm>
+          <a:prstGeom prst="line">
+            <a:avLst/>
+          </a:prstGeom>
+          <a:noFill/>
+          <a:ln w="19050">
+            <a:solidFill>
+              <a:srgbClr val="4A7FB5"/>
+            </a:solidFill>
+            <a:prstDash val="solid"/>
+            <a:tailEnd type="triangle"/>
+          </a:ln>
+        </p:spPr>
+      </p:sp>
+      <p:sp>
+        <p:nvSpPr>
+          <p:cNvPr id="16" name="Text 14"/>
+          <p:cNvSpPr/>
+          <p:nvPr/>
+        </p:nvSpPr>
+        <p:spPr>
+          <a:xfrm>
+            <a:off x="3657600" y="1097280"/>
+            <a:ext cx="4846320" cy="365760"/>
+          </a:xfrm>
+          <a:prstGeom prst="rect">
+            <a:avLst/>
+          </a:prstGeom>
+          <a:noFill/>
+          <a:ln/>
+        </p:spPr>
+        <p:txBody>
+          <a:bodyPr wrap="square" rtlCol="0" anchor="ctr"/>
+          <a:lstStyle/>
+          <a:p>
+            <a:pPr algn="ctr" indent="0" marL="0">
+              <a:buNone/>
+            </a:pPr>
+            <a:r>
+              <a:rPr lang="en-US" sz="1400" b="1" dirty="0">
+                <a:solidFill>
+                  <a:srgbClr val="2D2D2D"/>
+                </a:solidFill>
+                <a:latin typeface="Calibri" pitchFamily="34" charset="0"/>
+                <a:ea typeface="Calibri" pitchFamily="34" charset="-122"/>
+                <a:cs typeface="Calibri" pitchFamily="34" charset="-120"/>
+              </a:rPr>
+              <a:t>Future Pathways</a:t>
             </a:r>
             <a:endParaRPr lang="en-US" sz="1400" dirty="0"/>
+          </a:p>
+        </p:txBody>
+      </p:sp>
+      <p:sp>
+        <p:nvSpPr>
+          <p:cNvPr id="17" name="Shape 15"/>
+          <p:cNvSpPr/>
+          <p:nvPr/>
+        </p:nvSpPr>
+        <p:spPr>
+          <a:xfrm>
+            <a:off x="3657600" y="1645920"/>
+            <a:ext cx="4846320" cy="640080"/>
+          </a:xfrm>
+          <a:prstGeom prst="roundRect">
+            <a:avLst>
+              <a:gd name="adj" fmla="val 11429"/>
+            </a:avLst>
+          </a:prstGeom>
+          <a:solidFill>
+            <a:srgbClr val="FAFAFA"/>
+          </a:solidFill>
+          <a:ln w="10160">
+            <a:solidFill>
+              <a:srgbClr val="CCCCCC"/>
+            </a:solidFill>
+            <a:prstDash val="dash"/>
+          </a:ln>
+        </p:spPr>
+      </p:sp>
+      <p:sp>
+        <p:nvSpPr>
+          <p:cNvPr id="18" name="Text 16"/>
+          <p:cNvSpPr/>
+          <p:nvPr/>
+        </p:nvSpPr>
+        <p:spPr>
+          <a:xfrm>
+            <a:off x="3794760" y="1691640"/>
+            <a:ext cx="1645920" cy="548640"/>
+          </a:xfrm>
+          <a:prstGeom prst="rect">
+            <a:avLst/>
+          </a:prstGeom>
+          <a:noFill/>
+          <a:ln/>
+        </p:spPr>
+        <p:txBody>
+          <a:bodyPr wrap="square" rtlCol="0" anchor="ctr"/>
+          <a:lstStyle/>
+          <a:p>
+            <a:pPr indent="0" marL="0">
+              <a:buNone/>
+            </a:pPr>
+            <a:r>
+              <a:rPr lang="en-US" sz="1100" b="1" dirty="0">
+                <a:solidFill>
+                  <a:srgbClr val="2D2D2D"/>
+                </a:solidFill>
+                <a:latin typeface="Calibri" pitchFamily="34" charset="0"/>
+                <a:ea typeface="Calibri" pitchFamily="34" charset="-122"/>
+                <a:cs typeface="Calibri" pitchFamily="34" charset="-120"/>
+              </a:rPr>
+              <a:t>Demand integration</a:t>
+            </a:r>
+            <a:endParaRPr lang="en-US" sz="1100" dirty="0"/>
+          </a:p>
+        </p:txBody>
+      </p:sp>
+      <p:sp>
+        <p:nvSpPr>
+          <p:cNvPr id="19" name="Text 17"/>
+          <p:cNvSpPr/>
+          <p:nvPr/>
+        </p:nvSpPr>
+        <p:spPr>
+          <a:xfrm>
+            <a:off x="5486400" y="1691640"/>
+            <a:ext cx="2926080" cy="548640"/>
+          </a:xfrm>
+          <a:prstGeom prst="rect">
+            <a:avLst/>
+          </a:prstGeom>
+          <a:noFill/>
+          <a:ln/>
+        </p:spPr>
+        <p:txBody>
+          <a:bodyPr wrap="square" rtlCol="0" anchor="ctr"/>
+          <a:lstStyle/>
+          <a:p>
+            <a:pPr indent="0" marL="0">
+              <a:lnSpc>
+                <a:spcPct val="120000"/>
+              </a:lnSpc>
+              <a:buNone/>
+            </a:pPr>
+            <a:r>
+              <a:rPr lang="en-US" sz="1000" dirty="0">
+                <a:solidFill>
+                  <a:srgbClr val="777777"/>
+                </a:solidFill>
+                <a:latin typeface="Calibri" pitchFamily="34" charset="0"/>
+                <a:ea typeface="Calibri" pitchFamily="34" charset="-122"/>
+                <a:cs typeface="Calibri" pitchFamily="34" charset="-120"/>
+              </a:rPr>
+              <a:t>Combine with vacancy data to predict</a:t>
+            </a:r>
+            <a:endParaRPr lang="en-US" sz="1000" dirty="0"/>
+          </a:p>
+          <a:p>
+            <a:pPr indent="0" marL="0">
+              <a:lnSpc>
+                <a:spcPct val="120000"/>
+              </a:lnSpc>
+              <a:buNone/>
+            </a:pPr>
+            <a:r>
+              <a:rPr lang="en-US" sz="1000" dirty="0">
+                <a:solidFill>
+                  <a:srgbClr val="777777"/>
+                </a:solidFill>
+                <a:latin typeface="Calibri" pitchFamily="34" charset="0"/>
+                <a:ea typeface="Calibri" pitchFamily="34" charset="-122"/>
+                <a:cs typeface="Calibri" pitchFamily="34" charset="-120"/>
+              </a:rPr>
+              <a:t>realized flows, not just feasibility</a:t>
+            </a:r>
+            <a:endParaRPr lang="en-US" sz="1000" dirty="0"/>
+          </a:p>
+        </p:txBody>
+      </p:sp>
+      <p:sp>
+        <p:nvSpPr>
+          <p:cNvPr id="20" name="Shape 18"/>
+          <p:cNvSpPr/>
+          <p:nvPr/>
+        </p:nvSpPr>
+        <p:spPr>
+          <a:xfrm>
+            <a:off x="3657600" y="2423160"/>
+            <a:ext cx="4846320" cy="640080"/>
+          </a:xfrm>
+          <a:prstGeom prst="roundRect">
+            <a:avLst>
+              <a:gd name="adj" fmla="val 11429"/>
+            </a:avLst>
+          </a:prstGeom>
+          <a:solidFill>
+            <a:srgbClr val="FAFAFA"/>
+          </a:solidFill>
+          <a:ln w="10160">
+            <a:solidFill>
+              <a:srgbClr val="CCCCCC"/>
+            </a:solidFill>
+            <a:prstDash val="dash"/>
+          </a:ln>
+        </p:spPr>
+      </p:sp>
+      <p:sp>
+        <p:nvSpPr>
+          <p:cNvPr id="21" name="Text 19"/>
+          <p:cNvSpPr/>
+          <p:nvPr/>
+        </p:nvSpPr>
+        <p:spPr>
+          <a:xfrm>
+            <a:off x="3794760" y="2468880"/>
+            <a:ext cx="1645920" cy="548640"/>
+          </a:xfrm>
+          <a:prstGeom prst="rect">
+            <a:avLst/>
+          </a:prstGeom>
+          <a:noFill/>
+          <a:ln/>
+        </p:spPr>
+        <p:txBody>
+          <a:bodyPr wrap="square" rtlCol="0" anchor="ctr"/>
+          <a:lstStyle/>
+          <a:p>
+            <a:pPr indent="0" marL="0">
+              <a:buNone/>
+            </a:pPr>
+            <a:r>
+              <a:rPr lang="en-US" sz="1100" b="1" dirty="0">
+                <a:solidFill>
+                  <a:srgbClr val="2D2D2D"/>
+                </a:solidFill>
+                <a:latin typeface="Calibri" pitchFamily="34" charset="0"/>
+                <a:ea typeface="Calibri" pitchFamily="34" charset="-122"/>
+                <a:cs typeface="Calibri" pitchFamily="34" charset="-120"/>
+              </a:rPr>
+              <a:t>Individual wage data</a:t>
+            </a:r>
+            <a:endParaRPr lang="en-US" sz="1100" dirty="0"/>
+          </a:p>
+        </p:txBody>
+      </p:sp>
+      <p:sp>
+        <p:nvSpPr>
+          <p:cNvPr id="22" name="Text 20"/>
+          <p:cNvSpPr/>
+          <p:nvPr/>
+        </p:nvSpPr>
+        <p:spPr>
+          <a:xfrm>
+            <a:off x="5486400" y="2468880"/>
+            <a:ext cx="2926080" cy="548640"/>
+          </a:xfrm>
+          <a:prstGeom prst="rect">
+            <a:avLst/>
+          </a:prstGeom>
+          <a:noFill/>
+          <a:ln/>
+        </p:spPr>
+        <p:txBody>
+          <a:bodyPr wrap="square" rtlCol="0" anchor="ctr"/>
+          <a:lstStyle/>
+          <a:p>
+            <a:pPr indent="0" marL="0">
+              <a:lnSpc>
+                <a:spcPct val="120000"/>
+              </a:lnSpc>
+              <a:buNone/>
+            </a:pPr>
+            <a:r>
+              <a:rPr lang="en-US" sz="1000" dirty="0">
+                <a:solidFill>
+                  <a:srgbClr val="777777"/>
+                </a:solidFill>
+                <a:latin typeface="Calibri" pitchFamily="34" charset="0"/>
+                <a:ea typeface="Calibri" pitchFamily="34" charset="-122"/>
+                <a:cs typeface="Calibri" pitchFamily="34" charset="-120"/>
+              </a:rPr>
+              <a:t>Identify switching costs structurally</a:t>
+            </a:r>
+            <a:endParaRPr lang="en-US" sz="1000" dirty="0"/>
+          </a:p>
+          <a:p>
+            <a:pPr indent="0" marL="0">
+              <a:lnSpc>
+                <a:spcPct val="120000"/>
+              </a:lnSpc>
+              <a:buNone/>
+            </a:pPr>
+            <a:r>
+              <a:rPr lang="en-US" sz="1000" dirty="0">
+                <a:solidFill>
+                  <a:srgbClr val="777777"/>
+                </a:solidFill>
+                <a:latin typeface="Calibri" pitchFamily="34" charset="0"/>
+                <a:ea typeface="Calibri" pitchFamily="34" charset="-122"/>
+                <a:cs typeface="Calibri" pitchFamily="34" charset="-120"/>
+              </a:rPr>
+              <a:t>rather than calibrating externally</a:t>
+            </a:r>
+            <a:endParaRPr lang="en-US" sz="1000" dirty="0"/>
+          </a:p>
+        </p:txBody>
+      </p:sp>
+      <p:sp>
+        <p:nvSpPr>
+          <p:cNvPr id="23" name="Shape 21"/>
+          <p:cNvSpPr/>
+          <p:nvPr/>
+        </p:nvSpPr>
+        <p:spPr>
+          <a:xfrm>
+            <a:off x="3657600" y="3200400"/>
+            <a:ext cx="4846320" cy="640080"/>
+          </a:xfrm>
+          <a:prstGeom prst="roundRect">
+            <a:avLst>
+              <a:gd name="adj" fmla="val 11429"/>
+            </a:avLst>
+          </a:prstGeom>
+          <a:solidFill>
+            <a:srgbClr val="FAFAFA"/>
+          </a:solidFill>
+          <a:ln w="10160">
+            <a:solidFill>
+              <a:srgbClr val="CCCCCC"/>
+            </a:solidFill>
+            <a:prstDash val="dash"/>
+          </a:ln>
+        </p:spPr>
+      </p:sp>
+      <p:sp>
+        <p:nvSpPr>
+          <p:cNvPr id="24" name="Text 22"/>
+          <p:cNvSpPr/>
+          <p:nvPr/>
+        </p:nvSpPr>
+        <p:spPr>
+          <a:xfrm>
+            <a:off x="3794760" y="3246120"/>
+            <a:ext cx="1645920" cy="548640"/>
+          </a:xfrm>
+          <a:prstGeom prst="rect">
+            <a:avLst/>
+          </a:prstGeom>
+          <a:noFill/>
+          <a:ln/>
+        </p:spPr>
+        <p:txBody>
+          <a:bodyPr wrap="square" rtlCol="0" anchor="ctr"/>
+          <a:lstStyle/>
+          <a:p>
+            <a:pPr indent="0" marL="0">
+              <a:buNone/>
+            </a:pPr>
+            <a:r>
+              <a:rPr lang="en-US" sz="1100" b="1" dirty="0">
+                <a:solidFill>
+                  <a:srgbClr val="2D2D2D"/>
+                </a:solidFill>
+                <a:latin typeface="Calibri" pitchFamily="34" charset="0"/>
+                <a:ea typeface="Calibri" pitchFamily="34" charset="-122"/>
+                <a:cs typeface="Calibri" pitchFamily="34" charset="-120"/>
+              </a:rPr>
+              <a:t>Dynamic task content</a:t>
+            </a:r>
+            <a:endParaRPr lang="en-US" sz="1100" dirty="0"/>
+          </a:p>
+        </p:txBody>
+      </p:sp>
+      <p:sp>
+        <p:nvSpPr>
+          <p:cNvPr id="25" name="Text 23"/>
+          <p:cNvSpPr/>
+          <p:nvPr/>
+        </p:nvSpPr>
+        <p:spPr>
+          <a:xfrm>
+            <a:off x="5486400" y="3246120"/>
+            <a:ext cx="2926080" cy="548640"/>
+          </a:xfrm>
+          <a:prstGeom prst="rect">
+            <a:avLst/>
+          </a:prstGeom>
+          <a:noFill/>
+          <a:ln/>
+        </p:spPr>
+        <p:txBody>
+          <a:bodyPr wrap="square" rtlCol="0" anchor="ctr"/>
+          <a:lstStyle/>
+          <a:p>
+            <a:pPr indent="0" marL="0">
+              <a:lnSpc>
+                <a:spcPct val="120000"/>
+              </a:lnSpc>
+              <a:buNone/>
+            </a:pPr>
+            <a:r>
+              <a:rPr lang="en-US" sz="1000" dirty="0">
+                <a:solidFill>
+                  <a:srgbClr val="777777"/>
+                </a:solidFill>
+                <a:latin typeface="Calibri" pitchFamily="34" charset="0"/>
+                <a:ea typeface="Calibri" pitchFamily="34" charset="-122"/>
+                <a:cs typeface="Calibri" pitchFamily="34" charset="-120"/>
+              </a:rPr>
+              <a:t>Track how occupations’ task profiles</a:t>
+            </a:r>
+            <a:endParaRPr lang="en-US" sz="1000" dirty="0"/>
+          </a:p>
+          <a:p>
+            <a:pPr indent="0" marL="0">
+              <a:lnSpc>
+                <a:spcPct val="120000"/>
+              </a:lnSpc>
+              <a:buNone/>
+            </a:pPr>
+            <a:r>
+              <a:rPr lang="en-US" sz="1000" dirty="0">
+                <a:solidFill>
+                  <a:srgbClr val="777777"/>
+                </a:solidFill>
+                <a:latin typeface="Calibri" pitchFamily="34" charset="0"/>
+                <a:ea typeface="Calibri" pitchFamily="34" charset="-122"/>
+                <a:cs typeface="Calibri" pitchFamily="34" charset="-120"/>
+              </a:rPr>
+              <a:t>evolve as technology diffuses</a:t>
+            </a:r>
+            <a:endParaRPr lang="en-US" sz="1000" dirty="0"/>
+          </a:p>
+        </p:txBody>
+      </p:sp>
+      <p:sp>
+        <p:nvSpPr>
+          <p:cNvPr id="26" name="Shape 24"/>
+          <p:cNvSpPr/>
+          <p:nvPr/>
+        </p:nvSpPr>
+        <p:spPr>
+          <a:xfrm>
+            <a:off x="3657600" y="3977640"/>
+            <a:ext cx="4846320" cy="640080"/>
+          </a:xfrm>
+          <a:prstGeom prst="roundRect">
+            <a:avLst>
+              <a:gd name="adj" fmla="val 11429"/>
+            </a:avLst>
+          </a:prstGeom>
+          <a:solidFill>
+            <a:srgbClr val="FAFAFA"/>
+          </a:solidFill>
+          <a:ln w="10160">
+            <a:solidFill>
+              <a:srgbClr val="CCCCCC"/>
+            </a:solidFill>
+            <a:prstDash val="dash"/>
+          </a:ln>
+        </p:spPr>
+      </p:sp>
+      <p:sp>
+        <p:nvSpPr>
+          <p:cNvPr id="27" name="Text 25"/>
+          <p:cNvSpPr/>
+          <p:nvPr/>
+        </p:nvSpPr>
+        <p:spPr>
+          <a:xfrm>
+            <a:off x="3794760" y="4023360"/>
+            <a:ext cx="1645920" cy="548640"/>
+          </a:xfrm>
+          <a:prstGeom prst="rect">
+            <a:avLst/>
+          </a:prstGeom>
+          <a:noFill/>
+          <a:ln/>
+        </p:spPr>
+        <p:txBody>
+          <a:bodyPr wrap="square" rtlCol="0" anchor="ctr"/>
+          <a:lstStyle/>
+          <a:p>
+            <a:pPr indent="0" marL="0">
+              <a:buNone/>
+            </a:pPr>
+            <a:r>
+              <a:rPr lang="en-US" sz="1100" b="1" dirty="0">
+                <a:solidFill>
+                  <a:srgbClr val="2D2D2D"/>
+                </a:solidFill>
+                <a:latin typeface="Calibri" pitchFamily="34" charset="0"/>
+                <a:ea typeface="Calibri" pitchFamily="34" charset="-122"/>
+                <a:cs typeface="Calibri" pitchFamily="34" charset="-120"/>
+              </a:rPr>
+              <a:t>Technology shock modeling</a:t>
+            </a:r>
+            <a:endParaRPr lang="en-US" sz="1100" dirty="0"/>
+          </a:p>
+        </p:txBody>
+      </p:sp>
+      <p:sp>
+        <p:nvSpPr>
+          <p:cNvPr id="28" name="Text 26"/>
+          <p:cNvSpPr/>
+          <p:nvPr/>
+        </p:nvSpPr>
+        <p:spPr>
+          <a:xfrm>
+            <a:off x="5486400" y="4023360"/>
+            <a:ext cx="2926080" cy="548640"/>
+          </a:xfrm>
+          <a:prstGeom prst="rect">
+            <a:avLst/>
+          </a:prstGeom>
+          <a:noFill/>
+          <a:ln/>
+        </p:spPr>
+        <p:txBody>
+          <a:bodyPr wrap="square" rtlCol="0" anchor="ctr"/>
+          <a:lstStyle/>
+          <a:p>
+            <a:pPr indent="0" marL="0">
+              <a:lnSpc>
+                <a:spcPct val="120000"/>
+              </a:lnSpc>
+              <a:buNone/>
+            </a:pPr>
+            <a:r>
+              <a:rPr lang="en-US" sz="1000" dirty="0">
+                <a:solidFill>
+                  <a:srgbClr val="777777"/>
+                </a:solidFill>
+                <a:latin typeface="Calibri" pitchFamily="34" charset="0"/>
+                <a:ea typeface="Calibri" pitchFamily="34" charset="-122"/>
+                <a:cs typeface="Calibri" pitchFamily="34" charset="-120"/>
+              </a:rPr>
+              <a:t>Model AI exposure as a function of</a:t>
+            </a:r>
+            <a:endParaRPr lang="en-US" sz="1000" dirty="0"/>
+          </a:p>
+          <a:p>
+            <a:pPr indent="0" marL="0">
+              <a:lnSpc>
+                <a:spcPct val="120000"/>
+              </a:lnSpc>
+              <a:buNone/>
+            </a:pPr>
+            <a:r>
+              <a:rPr lang="en-US" sz="1000" dirty="0">
+                <a:solidFill>
+                  <a:srgbClr val="777777"/>
+                </a:solidFill>
+                <a:latin typeface="Calibri" pitchFamily="34" charset="0"/>
+                <a:ea typeface="Calibri" pitchFamily="34" charset="-122"/>
+                <a:cs typeface="Calibri" pitchFamily="34" charset="-120"/>
+              </a:rPr>
+              <a:t>task embeddings, not static scores</a:t>
+            </a:r>
+            <a:endParaRPr lang="en-US" sz="1000" dirty="0"/>
           </a:p>
         </p:txBody>
       </p:sp>

</xml_diff>

<commit_message>
v0.7.12.21: Slide 9 — Results label, matched heights, centered arrow
Co-Authored-By: Claude Opus 4.6 <noreply@anthropic.com>
</commit_message>
<xml_diff>
--- a/writing/presentation/task_embeddings_deck.pptx
+++ b/writing/presentation/task_embeddings_deck.pptx
@@ -5831,7 +5831,7 @@
                 <a:ea typeface="Calibri" pitchFamily="34" charset="-122"/>
                 <a:cs typeface="Calibri" pitchFamily="34" charset="-120"/>
               </a:rPr>
-              <a:t>This Paper</a:t>
+              <a:t>Results</a:t>
             </a:r>
             <a:endParaRPr lang="en-US" sz="1400" dirty="0"/>
           </a:p>
@@ -5846,11 +5846,11 @@
         <p:spPr>
           <a:xfrm>
             <a:off x="457200" y="1645920"/>
-            <a:ext cx="2377440" cy="685800"/>
+            <a:ext cx="2377440" cy="822960"/>
           </a:xfrm>
           <a:prstGeom prst="roundRect">
             <a:avLst>
-              <a:gd name="adj" fmla="val 10667"/>
+              <a:gd name="adj" fmla="val 8889"/>
             </a:avLst>
           </a:prstGeom>
           <a:solidFill>
@@ -5911,7 +5911,7 @@
         </p:nvSpPr>
         <p:spPr>
           <a:xfrm>
-            <a:off x="457200" y="1993392"/>
+            <a:off x="457200" y="2057400"/>
             <a:ext cx="2377440" cy="274320"/>
           </a:xfrm>
           <a:prstGeom prst="rect">
@@ -5950,12 +5950,12 @@
         </p:nvSpPr>
         <p:spPr>
           <a:xfrm>
-            <a:off x="457200" y="2560320"/>
-            <a:ext cx="2377440" cy="685800"/>
+            <a:off x="457200" y="2697480"/>
+            <a:ext cx="2377440" cy="822960"/>
           </a:xfrm>
           <a:prstGeom prst="roundRect">
             <a:avLst>
-              <a:gd name="adj" fmla="val 10667"/>
+              <a:gd name="adj" fmla="val 8889"/>
             </a:avLst>
           </a:prstGeom>
           <a:solidFill>
@@ -5977,7 +5977,7 @@
         </p:nvSpPr>
         <p:spPr>
           <a:xfrm>
-            <a:off x="457200" y="2606040"/>
+            <a:off x="457200" y="2743200"/>
             <a:ext cx="2377440" cy="365760"/>
           </a:xfrm>
           <a:prstGeom prst="rect">
@@ -6016,7 +6016,7 @@
         </p:nvSpPr>
         <p:spPr>
           <a:xfrm>
-            <a:off x="457200" y="2907792"/>
+            <a:off x="457200" y="3108960"/>
             <a:ext cx="2377440" cy="274320"/>
           </a:xfrm>
           <a:prstGeom prst="rect">
@@ -6055,12 +6055,12 @@
         </p:nvSpPr>
         <p:spPr>
           <a:xfrm>
-            <a:off x="457200" y="3474720"/>
-            <a:ext cx="2377440" cy="685800"/>
+            <a:off x="457200" y="3749040"/>
+            <a:ext cx="2377440" cy="822960"/>
           </a:xfrm>
           <a:prstGeom prst="roundRect">
             <a:avLst>
-              <a:gd name="adj" fmla="val 10667"/>
+              <a:gd name="adj" fmla="val 8889"/>
             </a:avLst>
           </a:prstGeom>
           <a:solidFill>
@@ -6082,7 +6082,7 @@
         </p:nvSpPr>
         <p:spPr>
           <a:xfrm>
-            <a:off x="457200" y="3520440"/>
+            <a:off x="457200" y="3794760"/>
             <a:ext cx="2377440" cy="365760"/>
           </a:xfrm>
           <a:prstGeom prst="rect">
@@ -6121,7 +6121,7 @@
         </p:nvSpPr>
         <p:spPr>
           <a:xfrm>
-            <a:off x="457200" y="3822192"/>
+            <a:off x="457200" y="4160520"/>
             <a:ext cx="2377440" cy="274320"/>
           </a:xfrm>
           <a:prstGeom prst="rect">
@@ -6160,7 +6160,7 @@
         </p:nvSpPr>
         <p:spPr>
           <a:xfrm>
-            <a:off x="2926080" y="2514600"/>
+            <a:off x="2926080" y="3108960"/>
             <a:ext cx="548640" cy="0"/>
           </a:xfrm>
           <a:prstGeom prst="line">

</xml_diff>

<commit_message>
v0.7.12.21: Slide 8/9/10 text tweaks — trim, recompose, aggregation method
Co-Authored-By: Claude Opus 4.6 <noreply@anthropic.com>
</commit_message>
<xml_diff>
--- a/writing/presentation/task_embeddings_deck.pptx
+++ b/writing/presentation/task_embeddings_deck.pptx
@@ -2258,7 +2258,7 @@
                 <a:ea typeface="Calibri" pitchFamily="34" charset="-122"/>
                 <a:cs typeface="Calibri" pitchFamily="34" charset="-120"/>
               </a:rPr>
-              <a:t>The gain is from the embedding representation, not optimal transport.</a:t>
+              <a:t>The gain is from the embedding representation, not the aggregation method.</a:t>
             </a:r>
             <a:endParaRPr lang="en-US" sz="1500" dirty="0"/>
           </a:p>
@@ -5635,7 +5635,7 @@
                 <a:ea typeface="Calibri" pitchFamily="34" charset="-122"/>
                 <a:cs typeface="Calibri" pitchFamily="34" charset="-120"/>
               </a:rPr>
-              <a:t>Orthogonal to AI exposure (r = −0.02) and routine task intensity (r = −0.06). Distinct constructs.</a:t>
+              <a:t>Orthogonal to AI exposure (r = −0.02) and routine task intensity (r = −0.06).</a:t>
             </a:r>
             <a:endParaRPr lang="en-US" sz="1400" dirty="0"/>
           </a:p>
@@ -6593,7 +6593,7 @@
                 <a:ea typeface="Calibri" pitchFamily="34" charset="-122"/>
                 <a:cs typeface="Calibri" pitchFamily="34" charset="-120"/>
               </a:rPr>
-              <a:t>evolve as technology diffuses</a:t>
+              <a:t>recompose as technology diffuses</a:t>
             </a:r>
             <a:endParaRPr lang="en-US" sz="1000" dirty="0"/>
           </a:p>

</xml_diff>

<commit_message>
v0.7.13.1: Sprint close + advisor feedback — docs, slide 2/6/9
Co-Authored-By: Claude Opus 4.6 <noreply@anthropic.com>
</commit_message>
<xml_diff>
--- a/writing/presentation/task_embeddings_deck.pptx
+++ b/writing/presentation/task_embeddings_deck.pptx
@@ -3853,7 +3853,7 @@
                           <a:ea typeface="Calibri" pitchFamily="34" charset="-122"/>
                           <a:cs typeface="Calibri" pitchFamily="34" charset="-120"/>
                         </a:rPr>
-                        <a:t>Simple average</a:t>
+                        <a:t>Centroid</a:t>
                       </a:r>
                       <a:endParaRPr lang="en-US" sz="1300" dirty="0">
                         <a:latin typeface="Calibri" charset="0"/>
@@ -3921,7 +3921,7 @@
                           <a:ea typeface="Calibri" pitchFamily="34" charset="-122"/>
                           <a:cs typeface="Calibri" pitchFamily="34" charset="-120"/>
                         </a:rPr>
-                        <a:t>Optimal transport</a:t>
+                        <a:t>Distributional</a:t>
                       </a:r>
                       <a:endParaRPr lang="en-US" sz="1300" dirty="0">
                         <a:latin typeface="Calibri" charset="0"/>
@@ -3991,7 +3991,7 @@
                           <a:ea typeface="Calibri" pitchFamily="34" charset="-122"/>
                           <a:cs typeface="Calibri" pitchFamily="34" charset="-120"/>
                         </a:rPr>
-                        <a:t>O*NET ratings</a:t>
+                        <a:t>O*NET weights</a:t>
                       </a:r>
                       <a:endParaRPr lang="en-US" sz="1300" dirty="0">
                         <a:latin typeface="Calibri" charset="0"/>
@@ -4059,7 +4059,7 @@
                           <a:ea typeface="Calibri" pitchFamily="34" charset="-122"/>
                           <a:cs typeface="Calibri" pitchFamily="34" charset="-120"/>
                         </a:rPr>
-                        <a:t>Baseline</a:t>
+                        <a:t>Cosine</a:t>
                       </a:r>
                       <a:endParaRPr lang="en-US" sz="1300" dirty="0">
                         <a:latin typeface="Calibri" charset="0"/>
@@ -4127,7 +4127,7 @@
                           <a:ea typeface="Calibri" pitchFamily="34" charset="-122"/>
                           <a:cs typeface="Calibri" pitchFamily="34" charset="-120"/>
                         </a:rPr>
-                        <a:t>Identity control</a:t>
+                        <a:t>Euclidean</a:t>
                       </a:r>
                       <a:endParaRPr lang="en-US" sz="1300" dirty="0">
                         <a:latin typeface="Calibri" charset="0"/>
@@ -4265,7 +4265,7 @@
                           <a:ea typeface="Calibri" pitchFamily="34" charset="-122"/>
                           <a:cs typeface="Calibri" pitchFamily="34" charset="-120"/>
                         </a:rPr>
-                        <a:t>Centroid (primary)</a:t>
+                        <a:t>Centroid ★</a:t>
                       </a:r>
                       <a:endParaRPr lang="en-US" sz="1300" dirty="0">
                         <a:latin typeface="Calibri" charset="0"/>
@@ -4389,9 +4389,87 @@
           </a:graphicData>
         </a:graphic>
       </p:graphicFrame>
+      <p:sp>
+        <p:nvSpPr>
+          <p:cNvPr id="7" name="Text 4"/>
+          <p:cNvSpPr/>
+          <p:nvPr/>
+        </p:nvSpPr>
+        <p:spPr>
+          <a:xfrm>
+            <a:off x="3291840" y="1371600"/>
+            <a:ext cx="4572000" cy="274320"/>
+          </a:xfrm>
+          <a:prstGeom prst="rect">
+            <a:avLst/>
+          </a:prstGeom>
+          <a:noFill/>
+          <a:ln/>
+        </p:spPr>
+        <p:txBody>
+          <a:bodyPr wrap="square" rtlCol="0" anchor="ctr"/>
+          <a:lstStyle/>
+          <a:p>
+            <a:pPr algn="ctr" indent="0" marL="0">
+              <a:buNone/>
+            </a:pPr>
+            <a:r>
+              <a:rPr lang="en-US" sz="1100" i="1" dirty="0">
+                <a:solidFill>
+                  <a:srgbClr val="777777"/>
+                </a:solidFill>
+                <a:latin typeface="Calibri" pitchFamily="34" charset="0"/>
+                <a:ea typeface="Calibri" pitchFamily="34" charset="-122"/>
+                <a:cs typeface="Calibri" pitchFamily="34" charset="-120"/>
+              </a:rPr>
+              <a:t>Aggregation →</a:t>
+            </a:r>
+            <a:endParaRPr lang="en-US" sz="1100" dirty="0"/>
+          </a:p>
+        </p:txBody>
+      </p:sp>
+      <p:sp>
+        <p:nvSpPr>
+          <p:cNvPr id="8" name="Text 5"/>
+          <p:cNvSpPr/>
+          <p:nvPr/>
+        </p:nvSpPr>
+        <p:spPr>
+          <a:xfrm>
+            <a:off x="274320" y="1371600"/>
+            <a:ext cx="1828800" cy="274320"/>
+          </a:xfrm>
+          <a:prstGeom prst="rect">
+            <a:avLst/>
+          </a:prstGeom>
+          <a:noFill/>
+          <a:ln/>
+        </p:spPr>
+        <p:txBody>
+          <a:bodyPr wrap="square" rtlCol="0" anchor="ctr"/>
+          <a:lstStyle/>
+          <a:p>
+            <a:pPr algn="ctr" indent="0" marL="0">
+              <a:buNone/>
+            </a:pPr>
+            <a:r>
+              <a:rPr lang="en-US" sz="1100" i="1" dirty="0">
+                <a:solidFill>
+                  <a:srgbClr val="777777"/>
+                </a:solidFill>
+                <a:latin typeface="Calibri" pitchFamily="34" charset="0"/>
+                <a:ea typeface="Calibri" pitchFamily="34" charset="-122"/>
+                <a:cs typeface="Calibri" pitchFamily="34" charset="-120"/>
+              </a:rPr>
+              <a:t>Representation ↓</a:t>
+            </a:r>
+            <a:endParaRPr lang="en-US" sz="1100" dirty="0"/>
+          </a:p>
+        </p:txBody>
+      </p:sp>
       <p:pic>
         <p:nvPicPr>
-          <p:cNvPr id="7" name="Image 0" descr="../../figures/fig_logit_eq.png">    </p:cNvPr>
+          <p:cNvPr id="9" name="Image 0" descr="../../figures/fig_logit_eq.png">    </p:cNvPr>
           <p:cNvPicPr>
             <a:picLocks noChangeAspect="1"/>
           </p:cNvPicPr>
@@ -4415,7 +4493,7 @@
       </p:pic>
       <p:sp>
         <p:nvSpPr>
-          <p:cNvPr id="8" name="Text 4"/>
+          <p:cNvPr id="10" name="Text 6"/>
           <p:cNvSpPr/>
           <p:nvPr/>
         </p:nvSpPr>
@@ -6445,7 +6523,7 @@
                 <a:ea typeface="Calibri" pitchFamily="34" charset="-122"/>
                 <a:cs typeface="Calibri" pitchFamily="34" charset="-120"/>
               </a:rPr>
-              <a:t>Identify switching costs structurally</a:t>
+              <a:t>Measure actual wage penalties for</a:t>
             </a:r>
             <a:endParaRPr lang="en-US" sz="1000" dirty="0"/>
           </a:p>
@@ -6465,7 +6543,7 @@
                 <a:ea typeface="Calibri" pitchFamily="34" charset="-122"/>
                 <a:cs typeface="Calibri" pitchFamily="34" charset="-120"/>
               </a:rPr>
-              <a:t>rather than calibrating externally</a:t>
+              <a:t>switchers with individual-level data</a:t>
             </a:r>
             <a:endParaRPr lang="en-US" sz="1000" dirty="0"/>
           </a:p>

</xml_diff>

<commit_message>
v0.7.13.2: Slide 6 axis labels into table corner cell
Co-Authored-By: Claude Opus 4.6 <noreply@anthropic.com>
</commit_message>
<xml_diff>
--- a/writing/presentation/task_embeddings_deck.pptx
+++ b/writing/presentation/task_embeddings_deck.pptx
@@ -3787,7 +3787,39 @@
                       <a:pPr algn="ctr" indent="0" marL="0">
                         <a:buNone/>
                       </a:pPr>
-                      <a:endParaRPr lang="en-US" sz="1300" dirty="0">
+                      <a:r>
+                        <a:rPr lang="en-US" sz="900" b="1" i="1" dirty="0">
+                          <a:solidFill>
+                            <a:srgbClr val="FFFFFF"/>
+                          </a:solidFill>
+                          <a:latin typeface="Calibri" pitchFamily="34" charset="0"/>
+                          <a:ea typeface="Calibri" pitchFamily="34" charset="-122"/>
+                          <a:cs typeface="Calibri" pitchFamily="34" charset="-120"/>
+                        </a:rPr>
+                        <a:t>Representation ↓</a:t>
+                      </a:r>
+                      <a:endParaRPr lang="en-US" sz="900" dirty="0">
+                        <a:latin typeface="Calibri" charset="0"/>
+                        <a:ea typeface="Calibri" charset="0"/>
+                        <a:cs typeface="Calibri" charset="0"/>
+                      </a:endParaRPr>
+                    </a:p>
+                    <a:p>
+                      <a:pPr algn="ctr" indent="0" marL="0">
+                        <a:buNone/>
+                      </a:pPr>
+                      <a:r>
+                        <a:rPr lang="en-US" sz="900" b="1" i="1" dirty="0">
+                          <a:solidFill>
+                            <a:srgbClr val="FFFFFF"/>
+                          </a:solidFill>
+                          <a:latin typeface="Calibri" pitchFamily="34" charset="0"/>
+                          <a:ea typeface="Calibri" pitchFamily="34" charset="-122"/>
+                          <a:cs typeface="Calibri" pitchFamily="34" charset="-120"/>
+                        </a:rPr>
+                        <a:t>Aggregation →</a:t>
+                      </a:r>
+                      <a:endParaRPr lang="en-US" sz="900" dirty="0">
                         <a:latin typeface="Calibri" charset="0"/>
                         <a:ea typeface="Calibri" charset="0"/>
                         <a:cs typeface="Calibri" charset="0"/>
@@ -4389,87 +4421,9 @@
           </a:graphicData>
         </a:graphic>
       </p:graphicFrame>
-      <p:sp>
-        <p:nvSpPr>
-          <p:cNvPr id="7" name="Text 4"/>
-          <p:cNvSpPr/>
-          <p:nvPr/>
-        </p:nvSpPr>
-        <p:spPr>
-          <a:xfrm>
-            <a:off x="3291840" y="1371600"/>
-            <a:ext cx="4572000" cy="274320"/>
-          </a:xfrm>
-          <a:prstGeom prst="rect">
-            <a:avLst/>
-          </a:prstGeom>
-          <a:noFill/>
-          <a:ln/>
-        </p:spPr>
-        <p:txBody>
-          <a:bodyPr wrap="square" rtlCol="0" anchor="ctr"/>
-          <a:lstStyle/>
-          <a:p>
-            <a:pPr algn="ctr" indent="0" marL="0">
-              <a:buNone/>
-            </a:pPr>
-            <a:r>
-              <a:rPr lang="en-US" sz="1100" i="1" dirty="0">
-                <a:solidFill>
-                  <a:srgbClr val="777777"/>
-                </a:solidFill>
-                <a:latin typeface="Calibri" pitchFamily="34" charset="0"/>
-                <a:ea typeface="Calibri" pitchFamily="34" charset="-122"/>
-                <a:cs typeface="Calibri" pitchFamily="34" charset="-120"/>
-              </a:rPr>
-              <a:t>Aggregation →</a:t>
-            </a:r>
-            <a:endParaRPr lang="en-US" sz="1100" dirty="0"/>
-          </a:p>
-        </p:txBody>
-      </p:sp>
-      <p:sp>
-        <p:nvSpPr>
-          <p:cNvPr id="8" name="Text 5"/>
-          <p:cNvSpPr/>
-          <p:nvPr/>
-        </p:nvSpPr>
-        <p:spPr>
-          <a:xfrm>
-            <a:off x="274320" y="1371600"/>
-            <a:ext cx="1828800" cy="274320"/>
-          </a:xfrm>
-          <a:prstGeom prst="rect">
-            <a:avLst/>
-          </a:prstGeom>
-          <a:noFill/>
-          <a:ln/>
-        </p:spPr>
-        <p:txBody>
-          <a:bodyPr wrap="square" rtlCol="0" anchor="ctr"/>
-          <a:lstStyle/>
-          <a:p>
-            <a:pPr algn="ctr" indent="0" marL="0">
-              <a:buNone/>
-            </a:pPr>
-            <a:r>
-              <a:rPr lang="en-US" sz="1100" i="1" dirty="0">
-                <a:solidFill>
-                  <a:srgbClr val="777777"/>
-                </a:solidFill>
-                <a:latin typeface="Calibri" pitchFamily="34" charset="0"/>
-                <a:ea typeface="Calibri" pitchFamily="34" charset="-122"/>
-                <a:cs typeface="Calibri" pitchFamily="34" charset="-120"/>
-              </a:rPr>
-              <a:t>Representation ↓</a:t>
-            </a:r>
-            <a:endParaRPr lang="en-US" sz="1100" dirty="0"/>
-          </a:p>
-        </p:txBody>
-      </p:sp>
       <p:pic>
         <p:nvPicPr>
-          <p:cNvPr id="9" name="Image 0" descr="../../figures/fig_logit_eq.png">    </p:cNvPr>
+          <p:cNvPr id="7" name="Image 0" descr="../../figures/fig_logit_eq.png">    </p:cNvPr>
           <p:cNvPicPr>
             <a:picLocks noChangeAspect="1"/>
           </p:cNvPicPr>
@@ -4493,7 +4447,7 @@
       </p:pic>
       <p:sp>
         <p:nvSpPr>
-          <p:cNvPr id="10" name="Text 6"/>
+          <p:cNvPr id="8" name="Text 4"/>
           <p:cNvSpPr/>
           <p:nvPr/>
         </p:nvSpPr>

</xml_diff>

<commit_message>
v0.7.13.2: Slide 6 corner cell, slide 7 col width, fig7 arrow style
Co-Authored-By: Claude Opus 4.6 <noreply@anthropic.com>
</commit_message>
<xml_diff>
--- a/writing/presentation/task_embeddings_deck.pptx
+++ b/writing/presentation/task_embeddings_deck.pptx
@@ -3796,7 +3796,7 @@
                           <a:ea typeface="Calibri" pitchFamily="34" charset="-122"/>
                           <a:cs typeface="Calibri" pitchFamily="34" charset="-120"/>
                         </a:rPr>
-                        <a:t>Representation ↓</a:t>
+                        <a:t>Aggregation →</a:t>
                       </a:r>
                       <a:endParaRPr lang="en-US" sz="900" dirty="0">
                         <a:latin typeface="Calibri" charset="0"/>
@@ -3817,7 +3817,7 @@
                           <a:ea typeface="Calibri" pitchFamily="34" charset="-122"/>
                           <a:cs typeface="Calibri" pitchFamily="34" charset="-120"/>
                         </a:rPr>
-                        <a:t>Aggregation →</a:t>
+                        <a:t>Representation ↓</a:t>
                       </a:r>
                       <a:endParaRPr lang="en-US" sz="900" dirty="0">
                         <a:latin typeface="Calibri" charset="0"/>
@@ -4703,8 +4703,8 @@
             <a:tbl>
               <a:tblPr/>
               <a:tblGrid>
-                <a:gridCol w="1280160"/>
-                <a:gridCol w="822960"/>
+                <a:gridCol w="1188720"/>
+                <a:gridCol w="914400"/>
                 <a:gridCol w="822960"/>
               </a:tblGrid>
               <a:tr h="320040">

</xml_diff>

<commit_message>
v0.7.13.3: Slide 7 col widths, fig7 chevron arrows
Co-Authored-By: Claude Opus 4.6 <noreply@anthropic.com>
</commit_message>
<xml_diff>
--- a/writing/presentation/task_embeddings_deck.pptx
+++ b/writing/presentation/task_embeddings_deck.pptx
@@ -4703,9 +4703,9 @@
             <a:tbl>
               <a:tblPr/>
               <a:tblGrid>
-                <a:gridCol w="1188720"/>
-                <a:gridCol w="914400"/>
-                <a:gridCol w="822960"/>
+                <a:gridCol w="1280160"/>
+                <a:gridCol w="960120"/>
+                <a:gridCol w="777240"/>
               </a:tblGrid>
               <a:tr h="320040">
                 <a:tc>

</xml_diff>

<commit_message>
v0.7.13.5: Slide 3 — heatmap colorbar + bold labels
Co-Authored-By: Claude Opus 4.6 (1M context) <noreply@anthropic.com>
</commit_message>
<xml_diff>
--- a/writing/presentation/task_embeddings_deck.pptx
+++ b/writing/presentation/task_embeddings_deck.pptx
@@ -3109,8 +3109,8 @@
         </p:blipFill>
         <p:spPr>
           <a:xfrm>
-            <a:off x="457200" y="914400"/>
-            <a:ext cx="3474720" cy="3657600"/>
+            <a:off x="274320" y="914400"/>
+            <a:ext cx="3291840" cy="3657600"/>
           </a:xfrm>
           <a:prstGeom prst="rect">
             <a:avLst/>
@@ -3133,8 +3133,8 @@
         </p:blipFill>
         <p:spPr>
           <a:xfrm>
-            <a:off x="4206240" y="914400"/>
-            <a:ext cx="3566160" cy="3657600"/>
+            <a:off x="3749040" y="914400"/>
+            <a:ext cx="4754880" cy="3977640"/>
           </a:xfrm>
           <a:prstGeom prst="rect">
             <a:avLst/>

</xml_diff>

<commit_message>
v0.7.13.10: Remove Takeaways slide, rename Thank You → Questions?
Co-Authored-By: Claude Opus 4.6 (1M context) <noreply@anthropic.com>
</commit_message>
<xml_diff>
--- a/writing/presentation/task_embeddings_deck.pptx
+++ b/writing/presentation/task_embeddings_deck.pptx
@@ -16,10 +16,9 @@
     <p:sldId id="264" r:id="rId10"/>
     <p:sldId id="265" r:id="rId11"/>
     <p:sldId id="266" r:id="rId12"/>
-    <p:sldId id="267" r:id="rId13"/>
   </p:sldIdLst>
   <p:notesMasterIdLst>
-    <p:notesMasterId r:id="rId14"/>
+    <p:notesMasterId r:id="rId13"/>
   </p:notesMasterIdLst>
   <p:sldSz cx="9144000" cy="5143500"/>
   <p:notesSz cx="5143500" cy="9144000"/>
@@ -713,94 +712,6 @@
             <a:fld id="{F7021451-1387-4CA6-816F-3879F97B5CBC}" type="slidenum">
               <a:rPr lang="en-US"/>
               <a:t>11</a:t>
-            </a:fld>
-            <a:endParaRPr lang="en-US"/>
-          </a:p>
-        </p:txBody>
-      </p:sp>
-    </p:spTree>
-    <p:extLst>
-      <p:ext uri="{BB962C8B-B14F-4D97-AF65-F5344CB8AC3E}">
-        <p14:creationId xmlns:p14="http://schemas.microsoft.com/office/powerpoint/2010/main" val="1024086991"/>
-      </p:ext>
-    </p:extLst>
-  </p:cSld>
-  <p:clrMapOvr>
-    <a:masterClrMapping/>
-  </p:clrMapOvr>
-</p:notes>
-</file>
-
-<file path=ppt/notesSlides/notesSlide12.xml><?xml version="1.0" encoding="utf-8"?>
-<p:notes xmlns:a="http://schemas.openxmlformats.org/drawingml/2006/main" xmlns:r="http://schemas.openxmlformats.org/officeDocument/2006/relationships" xmlns:p="http://schemas.openxmlformats.org/presentationml/2006/main">
-  <p:cSld>
-    <p:spTree>
-      <p:nvGrpSpPr>
-        <p:cNvPr id="1" name=""/>
-        <p:cNvGrpSpPr/>
-        <p:nvPr/>
-      </p:nvGrpSpPr>
-      <p:grpSpPr>
-        <a:xfrm>
-          <a:off x="0" y="0"/>
-          <a:ext cx="0" cy="0"/>
-          <a:chOff x="0" y="0"/>
-          <a:chExt cx="0" cy="0"/>
-        </a:xfrm>
-      </p:grpSpPr>
-      <p:sp>
-        <p:nvSpPr>
-          <p:cNvPr id="2" name="Slide Image Placeholder 1"/>
-          <p:cNvSpPr>
-            <a:spLocks noGrp="1" noRot="1" noChangeAspect="1"/>
-          </p:cNvSpPr>
-          <p:nvPr>
-            <p:ph type="sldImg"/>
-          </p:nvPr>
-        </p:nvSpPr>
-        <p:spPr/>
-      </p:sp>
-      <p:sp>
-        <p:nvSpPr>
-          <p:cNvPr id="3" name="Notes Placeholder 2"/>
-          <p:cNvSpPr>
-            <a:spLocks noGrp="1"/>
-          </p:cNvSpPr>
-          <p:nvPr>
-            <p:ph type="body" idx="1"/>
-          </p:nvPr>
-        </p:nvSpPr>
-        <p:spPr/>
-        <p:txBody>
-          <a:bodyPr/>
-          <a:lstStyle/>
-          <a:p>
-            <a:r>
-              <a:rPr lang="en-US" dirty="0"/>
-              <a:t/>
-            </a:r>
-            <a:endParaRPr lang="en-US" dirty="0"/>
-          </a:p>
-        </p:txBody>
-      </p:sp>
-      <p:sp>
-        <p:nvSpPr>
-          <p:cNvPr id="4" name="Slide Number Placeholder 3"/>
-          <p:cNvSpPr>
-            <a:spLocks noGrp="1"/>
-          </p:cNvSpPr>
-          <p:nvPr>
-            <p:ph type="sldNum" sz="quarter" idx="10"/>
-          </p:nvPr>
-        </p:nvSpPr>
-        <p:spPr/>
-        <p:txBody>
-          <a:bodyPr/>
-          <a:lstStyle/>
-          <a:p>
-            <a:fld id="{F7021451-1387-4CA6-816F-3879F97B5CBC}" type="slidenum">
-              <a:rPr lang="en-US"/>
-              <a:t>12</a:t>
             </a:fld>
             <a:endParaRPr lang="en-US"/>
           </a:p>
@@ -2094,37 +2005,14 @@
       </p:grpSpPr>
       <p:sp>
         <p:nvSpPr>
-          <p:cNvPr id="2" name="Shape 0"/>
+          <p:cNvPr id="2" name="Text 0"/>
           <p:cNvSpPr/>
           <p:nvPr/>
         </p:nvSpPr>
         <p:spPr>
           <a:xfrm>
-            <a:off x="457200" y="137160"/>
-            <a:ext cx="8229600" cy="0"/>
-          </a:xfrm>
-          <a:prstGeom prst="line">
-            <a:avLst/>
-          </a:prstGeom>
-          <a:noFill/>
-          <a:ln w="19050">
-            <a:solidFill>
-              <a:srgbClr val="4A7FB5"/>
-            </a:solidFill>
-            <a:prstDash val="solid"/>
-          </a:ln>
-        </p:spPr>
-      </p:sp>
-      <p:sp>
-        <p:nvSpPr>
-          <p:cNvPr id="3" name="Text 1"/>
-          <p:cNvSpPr/>
-          <p:nvPr/>
-        </p:nvSpPr>
-        <p:spPr>
-          <a:xfrm>
-            <a:off x="457200" y="274320"/>
-            <a:ext cx="8229600" cy="548640"/>
+            <a:off x="457200" y="1645920"/>
+            <a:ext cx="8229600" cy="731520"/>
           </a:xfrm>
           <a:prstGeom prst="rect">
             <a:avLst/>
@@ -2133,14 +2021,14 @@
           <a:ln/>
         </p:spPr>
         <p:txBody>
-          <a:bodyPr wrap="square" lIns="0" tIns="0" rIns="0" bIns="0" rtlCol="0" anchor="ctr"/>
-          <a:lstStyle/>
-          <a:p>
-            <a:pPr indent="0" marL="0">
-              <a:buNone/>
-            </a:pPr>
-            <a:r>
-              <a:rPr lang="en-US" sz="2800" b="1" dirty="0">
+          <a:bodyPr wrap="square" rtlCol="0" anchor="ctr"/>
+          <a:lstStyle/>
+          <a:p>
+            <a:pPr algn="ctr" indent="0" marL="0">
+              <a:buNone/>
+            </a:pPr>
+            <a:r>
+              <a:rPr lang="en-US" sz="3200" b="1" dirty="0">
                 <a:solidFill>
                   <a:srgbClr val="2D2D2D"/>
                 </a:solidFill>
@@ -2148,22 +2036,22 @@
                 <a:ea typeface="Calibri" pitchFamily="34" charset="-122"/>
                 <a:cs typeface="Calibri" pitchFamily="34" charset="-120"/>
               </a:rPr>
-              <a:t>Takeaways</a:t>
-            </a:r>
-            <a:endParaRPr lang="en-US" sz="2800" dirty="0"/>
-          </a:p>
-        </p:txBody>
-      </p:sp>
-      <p:sp>
-        <p:nvSpPr>
-          <p:cNvPr id="4" name="Text 2"/>
+              <a:t>Questions?</a:t>
+            </a:r>
+            <a:endParaRPr lang="en-US" sz="3200" dirty="0"/>
+          </a:p>
+        </p:txBody>
+      </p:sp>
+      <p:sp>
+        <p:nvSpPr>
+          <p:cNvPr id="3" name="Text 1"/>
           <p:cNvSpPr/>
           <p:nvPr/>
         </p:nvSpPr>
         <p:spPr>
           <a:xfrm>
-            <a:off x="8229600" y="4754880"/>
-            <a:ext cx="640080" cy="274320"/>
+            <a:off x="457200" y="2743200"/>
+            <a:ext cx="8229600" cy="731520"/>
           </a:xfrm>
           <a:prstGeom prst="rect">
             <a:avLst/>
@@ -2175,53 +2063,14 @@
           <a:bodyPr wrap="square" rtlCol="0" anchor="ctr"/>
           <a:lstStyle/>
           <a:p>
-            <a:pPr algn="r" indent="0" marL="0">
-              <a:buNone/>
-            </a:pPr>
-            <a:r>
-              <a:rPr lang="en-US" sz="1000" dirty="0">
-                <a:solidFill>
-                  <a:srgbClr val="999999"/>
-                </a:solidFill>
-                <a:latin typeface="Calibri" pitchFamily="34" charset="0"/>
-                <a:ea typeface="Calibri" pitchFamily="34" charset="-122"/>
-                <a:cs typeface="Calibri" pitchFamily="34" charset="-120"/>
-              </a:rPr>
-              <a:t>10</a:t>
-            </a:r>
-            <a:endParaRPr lang="en-US" sz="1000" dirty="0"/>
-          </a:p>
-        </p:txBody>
-      </p:sp>
-      <p:sp>
-        <p:nvSpPr>
-          <p:cNvPr id="5" name="Text 3"/>
-          <p:cNvSpPr/>
-          <p:nvPr/>
-        </p:nvSpPr>
-        <p:spPr>
-          <a:xfrm>
-            <a:off x="457200" y="1005840"/>
-            <a:ext cx="8229600" cy="3840480"/>
-          </a:xfrm>
-          <a:prstGeom prst="rect">
-            <a:avLst/>
-          </a:prstGeom>
-          <a:noFill/>
-          <a:ln/>
-        </p:spPr>
-        <p:txBody>
-          <a:bodyPr wrap="square" rtlCol="0" anchor="t"/>
-          <a:lstStyle/>
-          <a:p>
-            <a:pPr indent="0" marL="0">
+            <a:pPr algn="ctr" indent="0" marL="0">
               <a:lnSpc>
-                <a:spcPct val="130000"/>
+                <a:spcPct val="150000"/>
               </a:lnSpc>
               <a:buNone/>
             </a:pPr>
             <a:r>
-              <a:rPr lang="en-US" sz="1500" dirty="0">
+              <a:rPr lang="en-US" sz="1600" dirty="0">
                 <a:solidFill>
                   <a:srgbClr val="2D2D2D"/>
                 </a:solidFill>
@@ -2229,28 +2078,19 @@
                 <a:ea typeface="Calibri" pitchFamily="34" charset="-122"/>
                 <a:cs typeface="Calibri" pitchFamily="34" charset="-120"/>
               </a:rPr>
-              <a:t>Embeddings improve transition prediction by 74.9% over O*NET baselines (pseudo-R²: 14.1% vs. 6–8%).</a:t>
-            </a:r>
-            <a:endParaRPr lang="en-US" sz="1500" dirty="0"/>
-          </a:p>
-          <a:p>
-            <a:pPr indent="0" marL="0">
+              <a:t>Spencer Hodge</a:t>
+            </a:r>
+            <a:endParaRPr lang="en-US" sz="1600" dirty="0"/>
+          </a:p>
+          <a:p>
+            <a:pPr algn="ctr" indent="0" marL="0">
               <a:lnSpc>
-                <a:spcPct val="130000"/>
+                <a:spcPct val="150000"/>
               </a:lnSpc>
               <a:buNone/>
             </a:pPr>
-            <a:endParaRPr lang="en-US" sz="1500" dirty="0"/>
-          </a:p>
-          <a:p>
-            <a:pPr indent="0" marL="0">
-              <a:lnSpc>
-                <a:spcPct val="130000"/>
-              </a:lnSpc>
-              <a:buNone/>
-            </a:pPr>
-            <a:r>
-              <a:rPr lang="en-US" sz="1500" dirty="0">
+            <a:r>
+              <a:rPr lang="en-US" sz="1600" dirty="0">
                 <a:solidFill>
                   <a:srgbClr val="2D2D2D"/>
                 </a:solidFill>
@@ -2258,98 +2098,73 @@
                 <a:ea typeface="Calibri" pitchFamily="34" charset="-122"/>
                 <a:cs typeface="Calibri" pitchFamily="34" charset="-120"/>
               </a:rPr>
-              <a:t>The gain is from the embedding representation, not the aggregation method.</a:t>
-            </a:r>
-            <a:endParaRPr lang="en-US" sz="1500" dirty="0"/>
-          </a:p>
-          <a:p>
-            <a:pPr indent="0" marL="0">
-              <a:lnSpc>
-                <a:spcPct val="130000"/>
-              </a:lnSpc>
-              <a:buNone/>
-            </a:pPr>
-            <a:endParaRPr lang="en-US" sz="1500" dirty="0"/>
-          </a:p>
-          <a:p>
-            <a:pPr indent="0" marL="0">
-              <a:lnSpc>
-                <a:spcPct val="130000"/>
-              </a:lnSpc>
-              <a:buNone/>
-            </a:pPr>
-            <a:r>
-              <a:rPr lang="en-US" sz="1500" dirty="0">
+              <a:t>shodge33@students.kennesaw.edu</a:t>
+            </a:r>
+            <a:endParaRPr lang="en-US" sz="1600" dirty="0"/>
+          </a:p>
+        </p:txBody>
+      </p:sp>
+      <p:sp>
+        <p:nvSpPr>
+          <p:cNvPr id="4" name="Text 2"/>
+          <p:cNvSpPr/>
+          <p:nvPr/>
+        </p:nvSpPr>
+        <p:spPr>
+          <a:xfrm>
+            <a:off x="457200" y="3657600"/>
+            <a:ext cx="8229600" cy="457200"/>
+          </a:xfrm>
+          <a:prstGeom prst="rect">
+            <a:avLst/>
+          </a:prstGeom>
+          <a:noFill/>
+          <a:ln/>
+        </p:spPr>
+        <p:txBody>
+          <a:bodyPr wrap="square" rtlCol="0" anchor="ctr"/>
+          <a:lstStyle/>
+          <a:p>
+            <a:pPr algn="ctr" indent="0" marL="0">
+              <a:buNone/>
+            </a:pPr>
+            <a:r>
+              <a:rPr lang="en-US" sz="1400" dirty="0">
                 <a:solidFill>
-                  <a:srgbClr val="2D2D2D"/>
+                  <a:srgbClr val="4A7FB5"/>
                 </a:solidFill>
                 <a:latin typeface="Calibri" pitchFamily="34" charset="0"/>
                 <a:ea typeface="Calibri" pitchFamily="34" charset="-122"/>
                 <a:cs typeface="Calibri" pitchFamily="34" charset="-120"/>
               </a:rPr>
-              <a:t>Captures within-origin pathway feasibility, not aggregate allocation.</a:t>
-            </a:r>
-            <a:endParaRPr lang="en-US" sz="1500" dirty="0"/>
-          </a:p>
-          <a:p>
-            <a:pPr indent="0" marL="0">
-              <a:lnSpc>
-                <a:spcPct val="130000"/>
-              </a:lnSpc>
-              <a:buNone/>
-            </a:pPr>
-            <a:endParaRPr lang="en-US" sz="1500" dirty="0"/>
-          </a:p>
-          <a:p>
-            <a:pPr indent="0" marL="0">
-              <a:lnSpc>
-                <a:spcPct val="130000"/>
-              </a:lnSpc>
-              <a:buNone/>
-            </a:pPr>
-            <a:r>
-              <a:rPr lang="en-US" sz="1500" dirty="0">
-                <a:solidFill>
-                  <a:srgbClr val="2D2D2D"/>
-                </a:solidFill>
-                <a:latin typeface="Calibri" pitchFamily="34" charset="0"/>
-                <a:ea typeface="Calibri" pitchFamily="34" charset="-122"/>
-                <a:cs typeface="Calibri" pitchFamily="34" charset="-120"/>
-              </a:rPr>
-              <a:t>Orthogonal to AI exposure (r = −0.02) and routine task intensity (r = −0.06).</a:t>
-            </a:r>
-            <a:endParaRPr lang="en-US" sz="1500" dirty="0"/>
-          </a:p>
-          <a:p>
-            <a:pPr indent="0" marL="0">
-              <a:lnSpc>
-                <a:spcPct val="130000"/>
-              </a:lnSpc>
-              <a:buNone/>
-            </a:pPr>
-            <a:endParaRPr lang="en-US" sz="1500" dirty="0"/>
-          </a:p>
-          <a:p>
-            <a:pPr indent="0" marL="0">
-              <a:lnSpc>
-                <a:spcPct val="130000"/>
-              </a:lnSpc>
-              <a:buNone/>
-            </a:pPr>
-            <a:r>
-              <a:rPr lang="en-US" sz="1500" dirty="0">
-                <a:solidFill>
-                  <a:srgbClr val="2D2D2D"/>
-                </a:solidFill>
-                <a:latin typeface="Calibri" pitchFamily="34" charset="0"/>
-                <a:ea typeface="Calibri" pitchFamily="34" charset="-122"/>
-                <a:cs typeface="Calibri" pitchFamily="34" charset="-120"/>
-              </a:rPr>
-              <a:t>Stable pre/post COVID (Δα &lt; 1%, p = 0.72).</a:t>
-            </a:r>
-            <a:endParaRPr lang="en-US" sz="1500" dirty="0"/>
-          </a:p>
-        </p:txBody>
+              <a:t>Code &amp; data: github.com/spencer2718/task-space-model</a:t>
+            </a:r>
+            <a:endParaRPr lang="en-US" sz="1400" dirty="0"/>
+          </a:p>
+        </p:txBody>
+      </p:sp>
+      <p:sp>
+        <p:nvSpPr>
+          <p:cNvPr id="5" name="Shape 3"/>
+          <p:cNvSpPr/>
+          <p:nvPr/>
+        </p:nvSpPr>
+        <p:spPr>
+          <a:xfrm>
+            <a:off x="3200400" y="2606040"/>
+            <a:ext cx="2743200" cy="0"/>
+          </a:xfrm>
+          <a:prstGeom prst="line">
+            <a:avLst/>
+          </a:prstGeom>
+          <a:noFill/>
+          <a:ln w="12700">
+            <a:solidFill>
+              <a:srgbClr val="4A7FB5"/>
+            </a:solidFill>
+            <a:prstDash val="solid"/>
+          </a:ln>
+        </p:spPr>
       </p:sp>
     </p:spTree>
   </p:cSld>
@@ -2362,201 +2177,6 @@
 <file path=ppt/slides/slide11.xml><?xml version="1.0" encoding="utf-8"?>
 <p:sld xmlns:a="http://schemas.openxmlformats.org/drawingml/2006/main" xmlns:r="http://schemas.openxmlformats.org/officeDocument/2006/relationships" xmlns:p="http://schemas.openxmlformats.org/presentationml/2006/main">
   <p:cSld name="Slide 11">
-    <p:bg>
-      <p:bgPr>
-        <a:solidFill>
-          <a:srgbClr val="FFFFFF"/>
-        </a:solidFill>
-      </p:bgPr>
-    </p:bg>
-    <p:spTree>
-      <p:nvGrpSpPr>
-        <p:cNvPr id="1" name=""/>
-        <p:cNvGrpSpPr/>
-        <p:nvPr/>
-      </p:nvGrpSpPr>
-      <p:grpSpPr>
-        <a:xfrm>
-          <a:off x="0" y="0"/>
-          <a:ext cx="0" cy="0"/>
-          <a:chOff x="0" y="0"/>
-          <a:chExt cx="0" cy="0"/>
-        </a:xfrm>
-      </p:grpSpPr>
-      <p:sp>
-        <p:nvSpPr>
-          <p:cNvPr id="2" name="Text 0"/>
-          <p:cNvSpPr/>
-          <p:nvPr/>
-        </p:nvSpPr>
-        <p:spPr>
-          <a:xfrm>
-            <a:off x="457200" y="1645920"/>
-            <a:ext cx="8229600" cy="731520"/>
-          </a:xfrm>
-          <a:prstGeom prst="rect">
-            <a:avLst/>
-          </a:prstGeom>
-          <a:noFill/>
-          <a:ln/>
-        </p:spPr>
-        <p:txBody>
-          <a:bodyPr wrap="square" rtlCol="0" anchor="ctr"/>
-          <a:lstStyle/>
-          <a:p>
-            <a:pPr algn="ctr" indent="0" marL="0">
-              <a:buNone/>
-            </a:pPr>
-            <a:r>
-              <a:rPr lang="en-US" sz="3200" b="1" dirty="0">
-                <a:solidFill>
-                  <a:srgbClr val="2D2D2D"/>
-                </a:solidFill>
-                <a:latin typeface="Calibri" pitchFamily="34" charset="0"/>
-                <a:ea typeface="Calibri" pitchFamily="34" charset="-122"/>
-                <a:cs typeface="Calibri" pitchFamily="34" charset="-120"/>
-              </a:rPr>
-              <a:t>Thank You</a:t>
-            </a:r>
-            <a:endParaRPr lang="en-US" sz="3200" dirty="0"/>
-          </a:p>
-        </p:txBody>
-      </p:sp>
-      <p:sp>
-        <p:nvSpPr>
-          <p:cNvPr id="3" name="Text 1"/>
-          <p:cNvSpPr/>
-          <p:nvPr/>
-        </p:nvSpPr>
-        <p:spPr>
-          <a:xfrm>
-            <a:off x="457200" y="2743200"/>
-            <a:ext cx="8229600" cy="731520"/>
-          </a:xfrm>
-          <a:prstGeom prst="rect">
-            <a:avLst/>
-          </a:prstGeom>
-          <a:noFill/>
-          <a:ln/>
-        </p:spPr>
-        <p:txBody>
-          <a:bodyPr wrap="square" rtlCol="0" anchor="ctr"/>
-          <a:lstStyle/>
-          <a:p>
-            <a:pPr algn="ctr" indent="0" marL="0">
-              <a:lnSpc>
-                <a:spcPct val="150000"/>
-              </a:lnSpc>
-              <a:buNone/>
-            </a:pPr>
-            <a:r>
-              <a:rPr lang="en-US" sz="1600" dirty="0">
-                <a:solidFill>
-                  <a:srgbClr val="2D2D2D"/>
-                </a:solidFill>
-                <a:latin typeface="Calibri" pitchFamily="34" charset="0"/>
-                <a:ea typeface="Calibri" pitchFamily="34" charset="-122"/>
-                <a:cs typeface="Calibri" pitchFamily="34" charset="-120"/>
-              </a:rPr>
-              <a:t>Spencer Hodge</a:t>
-            </a:r>
-            <a:endParaRPr lang="en-US" sz="1600" dirty="0"/>
-          </a:p>
-          <a:p>
-            <a:pPr algn="ctr" indent="0" marL="0">
-              <a:lnSpc>
-                <a:spcPct val="150000"/>
-              </a:lnSpc>
-              <a:buNone/>
-            </a:pPr>
-            <a:r>
-              <a:rPr lang="en-US" sz="1600" dirty="0">
-                <a:solidFill>
-                  <a:srgbClr val="2D2D2D"/>
-                </a:solidFill>
-                <a:latin typeface="Calibri" pitchFamily="34" charset="0"/>
-                <a:ea typeface="Calibri" pitchFamily="34" charset="-122"/>
-                <a:cs typeface="Calibri" pitchFamily="34" charset="-120"/>
-              </a:rPr>
-              <a:t>shodge33@students.kennesaw.edu</a:t>
-            </a:r>
-            <a:endParaRPr lang="en-US" sz="1600" dirty="0"/>
-          </a:p>
-        </p:txBody>
-      </p:sp>
-      <p:sp>
-        <p:nvSpPr>
-          <p:cNvPr id="4" name="Text 2"/>
-          <p:cNvSpPr/>
-          <p:nvPr/>
-        </p:nvSpPr>
-        <p:spPr>
-          <a:xfrm>
-            <a:off x="457200" y="3657600"/>
-            <a:ext cx="8229600" cy="457200"/>
-          </a:xfrm>
-          <a:prstGeom prst="rect">
-            <a:avLst/>
-          </a:prstGeom>
-          <a:noFill/>
-          <a:ln/>
-        </p:spPr>
-        <p:txBody>
-          <a:bodyPr wrap="square" rtlCol="0" anchor="ctr"/>
-          <a:lstStyle/>
-          <a:p>
-            <a:pPr algn="ctr" indent="0" marL="0">
-              <a:buNone/>
-            </a:pPr>
-            <a:r>
-              <a:rPr lang="en-US" sz="1400" dirty="0">
-                <a:solidFill>
-                  <a:srgbClr val="4A7FB5"/>
-                </a:solidFill>
-                <a:latin typeface="Calibri" pitchFamily="34" charset="0"/>
-                <a:ea typeface="Calibri" pitchFamily="34" charset="-122"/>
-                <a:cs typeface="Calibri" pitchFamily="34" charset="-120"/>
-              </a:rPr>
-              <a:t>Code &amp; data: github.com/spencer2718/task-space-model</a:t>
-            </a:r>
-            <a:endParaRPr lang="en-US" sz="1400" dirty="0"/>
-          </a:p>
-        </p:txBody>
-      </p:sp>
-      <p:sp>
-        <p:nvSpPr>
-          <p:cNvPr id="5" name="Shape 3"/>
-          <p:cNvSpPr/>
-          <p:nvPr/>
-        </p:nvSpPr>
-        <p:spPr>
-          <a:xfrm>
-            <a:off x="3200400" y="2606040"/>
-            <a:ext cx="2743200" cy="0"/>
-          </a:xfrm>
-          <a:prstGeom prst="line">
-            <a:avLst/>
-          </a:prstGeom>
-          <a:noFill/>
-          <a:ln w="12700">
-            <a:solidFill>
-              <a:srgbClr val="4A7FB5"/>
-            </a:solidFill>
-            <a:prstDash val="solid"/>
-          </a:ln>
-        </p:spPr>
-      </p:sp>
-    </p:spTree>
-  </p:cSld>
-  <p:clrMapOvr>
-    <a:masterClrMapping/>
-  </p:clrMapOvr>
-</p:sld>
-</file>
-
-<file path=ppt/slides/slide12.xml><?xml version="1.0" encoding="utf-8"?>
-<p:sld xmlns:a="http://schemas.openxmlformats.org/drawingml/2006/main" xmlns:r="http://schemas.openxmlformats.org/officeDocument/2006/relationships" xmlns:p="http://schemas.openxmlformats.org/presentationml/2006/main">
-  <p:cSld name="Slide 12">
     <p:bg>
       <p:bgPr>
         <a:solidFill>

</xml_diff>